<commit_message>
Add key code snippets to presentation and report
</commit_message>
<xml_diff>
--- a/deliverables/Java_모의주식투자_발표자료.pptx
+++ b/deliverables/Java_모의주식투자_발표자료.pptx
@@ -19,9 +19,10 @@
     <p:sldId id="267" r:id="rId13"/>
     <p:sldId id="268" r:id="rId14"/>
     <p:sldId id="269" r:id="rId15"/>
+    <p:sldId id="270" r:id="rId16"/>
   </p:sldIdLst>
   <p:notesMasterIdLst>
-    <p:notesMasterId r:id="rId16"/>
+    <p:notesMasterId r:id="rId17"/>
   </p:notesMasterIdLst>
   <p:sldSz cx="12191695" cy="6858000"/>
   <p:notesSz cx="6858000" cy="12191695"/>
@@ -997,6 +998,94 @@
 </p:notes>
 </file>
 
+<file path=ppt/notesSlides/notesSlide15.xml><?xml version="1.0" encoding="utf-8"?>
+<p:notes xmlns:a="http://schemas.openxmlformats.org/drawingml/2006/main" xmlns:r="http://schemas.openxmlformats.org/officeDocument/2006/relationships" xmlns:p="http://schemas.openxmlformats.org/presentationml/2006/main">
+  <p:cSld>
+    <p:spTree>
+      <p:nvGrpSpPr>
+        <p:cNvPr id="1" name=""/>
+        <p:cNvGrpSpPr/>
+        <p:nvPr/>
+      </p:nvGrpSpPr>
+      <p:grpSpPr>
+        <a:xfrm>
+          <a:off x="0" y="0"/>
+          <a:ext cx="0" cy="0"/>
+          <a:chOff x="0" y="0"/>
+          <a:chExt cx="0" cy="0"/>
+        </a:xfrm>
+      </p:grpSpPr>
+      <p:sp>
+        <p:nvSpPr>
+          <p:cNvPr id="2" name="Slide Image Placeholder 1"/>
+          <p:cNvSpPr>
+            <a:spLocks noGrp="1" noRot="1" noChangeAspect="1"/>
+          </p:cNvSpPr>
+          <p:nvPr>
+            <p:ph type="sldImg"/>
+          </p:nvPr>
+        </p:nvSpPr>
+        <p:spPr/>
+      </p:sp>
+      <p:sp>
+        <p:nvSpPr>
+          <p:cNvPr id="3" name="Notes Placeholder 2"/>
+          <p:cNvSpPr>
+            <a:spLocks noGrp="1"/>
+          </p:cNvSpPr>
+          <p:nvPr>
+            <p:ph type="body" idx="1"/>
+          </p:nvPr>
+        </p:nvSpPr>
+        <p:spPr/>
+        <p:txBody>
+          <a:bodyPr/>
+          <a:lstStyle/>
+          <a:p>
+            <a:r>
+              <a:rPr lang="en-US" dirty="0"/>
+              <a:t/>
+            </a:r>
+            <a:endParaRPr lang="en-US" dirty="0"/>
+          </a:p>
+        </p:txBody>
+      </p:sp>
+      <p:sp>
+        <p:nvSpPr>
+          <p:cNvPr id="4" name="Slide Number Placeholder 3"/>
+          <p:cNvSpPr>
+            <a:spLocks noGrp="1"/>
+          </p:cNvSpPr>
+          <p:nvPr>
+            <p:ph type="sldNum" sz="quarter" idx="10"/>
+          </p:nvPr>
+        </p:nvSpPr>
+        <p:spPr/>
+        <p:txBody>
+          <a:bodyPr/>
+          <a:lstStyle/>
+          <a:p>
+            <a:fld id="{F7021451-1387-4CA6-816F-3879F97B5CBC}" type="slidenum">
+              <a:rPr lang="en-US"/>
+              <a:t>15</a:t>
+            </a:fld>
+            <a:endParaRPr lang="en-US"/>
+          </a:p>
+        </p:txBody>
+      </p:sp>
+    </p:spTree>
+    <p:extLst>
+      <p:ext uri="{BB962C8B-B14F-4D97-AF65-F5344CB8AC3E}">
+        <p14:creationId xmlns:p14="http://schemas.microsoft.com/office/powerpoint/2010/main" val="1024086991"/>
+      </p:ext>
+    </p:extLst>
+  </p:cSld>
+  <p:clrMapOvr>
+    <a:masterClrMapping/>
+  </p:clrMapOvr>
+</p:notes>
+</file>
+
 <file path=ppt/notesSlides/notesSlide2.xml><?xml version="1.0" encoding="utf-8"?>
 <p:notes xmlns:a="http://schemas.openxmlformats.org/drawingml/2006/main" xmlns:r="http://schemas.openxmlformats.org/officeDocument/2006/relationships" xmlns:p="http://schemas.openxmlformats.org/presentationml/2006/main">
   <p:cSld>
@@ -5772,7 +5861,7 @@
                 <a:ea typeface="Malgun Gothic" pitchFamily="34" charset="-122"/>
                 <a:cs typeface="Malgun Gothic" pitchFamily="34" charset="-120"/>
               </a:rPr>
-              <a:t>시연 영상 구성</a:t>
+              <a:t>주요 코드 일부</a:t>
             </a:r>
             <a:endParaRPr lang="en-US" sz="1600" dirty="0"/>
           </a:p>
@@ -5839,39 +5928,80 @@
       </p:sp>
       <p:sp>
         <p:nvSpPr>
-          <p:cNvPr id="6" name="Shape 4"/>
+          <p:cNvPr id="6" name="Text 4"/>
           <p:cNvSpPr/>
           <p:nvPr/>
         </p:nvSpPr>
         <p:spPr>
           <a:xfrm>
             <a:off x="594360" y="868680"/>
-            <a:ext cx="1152144" cy="585216"/>
-          </a:xfrm>
-          <a:prstGeom prst="rect">
-            <a:avLst/>
-          </a:prstGeom>
-          <a:solidFill>
-            <a:srgbClr val="122033"/>
-          </a:solidFill>
-          <a:ln w="7620">
-            <a:solidFill>
-              <a:srgbClr val="D7DEEA"/>
-            </a:solidFill>
-            <a:prstDash val="solid"/>
-          </a:ln>
-        </p:spPr>
-      </p:sp>
-      <p:sp>
-        <p:nvSpPr>
-          <p:cNvPr id="7" name="Text 5"/>
-          <p:cNvSpPr/>
-          <p:nvPr/>
-        </p:nvSpPr>
-        <p:spPr>
-          <a:xfrm>
-            <a:off x="667512" y="941832"/>
-            <a:ext cx="1005840" cy="457200"/>
+            <a:ext cx="5303520" cy="219456"/>
+          </a:xfrm>
+          <a:prstGeom prst="rect">
+            <a:avLst/>
+          </a:prstGeom>
+          <a:noFill/>
+          <a:ln/>
+        </p:spPr>
+        <p:txBody>
+          <a:bodyPr wrap="square" lIns="0" tIns="0" rIns="0" bIns="0" rtlCol="0" anchor="ctr"/>
+          <a:lstStyle/>
+          <a:p>
+            <a:pPr indent="0" marL="0">
+              <a:buNone/>
+            </a:pPr>
+            <a:r>
+              <a:rPr lang="en-US" sz="1050" b="1" dirty="0">
+                <a:solidFill>
+                  <a:srgbClr val="1F5FBF"/>
+                </a:solidFill>
+                <a:latin typeface="Malgun Gothic" pitchFamily="34" charset="0"/>
+                <a:ea typeface="Malgun Gothic" pitchFamily="34" charset="-122"/>
+                <a:cs typeface="Malgun Gothic" pitchFamily="34" charset="-120"/>
+              </a:rPr>
+              <a:t>HTTP 라우팅 - MiniHandler.java</a:t>
+            </a:r>
+            <a:endParaRPr lang="en-US" sz="1050" dirty="0"/>
+          </a:p>
+        </p:txBody>
+      </p:sp>
+      <p:sp>
+        <p:nvSpPr>
+          <p:cNvPr id="7" name="Shape 5"/>
+          <p:cNvSpPr/>
+          <p:nvPr/>
+        </p:nvSpPr>
+        <p:spPr>
+          <a:xfrm>
+            <a:off x="594360" y="1161288"/>
+            <a:ext cx="5303520" cy="1719072"/>
+          </a:xfrm>
+          <a:prstGeom prst="roundRect">
+            <a:avLst>
+              <a:gd name="adj" fmla="val 2128"/>
+            </a:avLst>
+          </a:prstGeom>
+          <a:solidFill>
+            <a:srgbClr val="111827"/>
+          </a:solidFill>
+          <a:ln w="10160">
+            <a:solidFill>
+              <a:srgbClr val="334155"/>
+            </a:solidFill>
+            <a:prstDash val="solid"/>
+          </a:ln>
+        </p:spPr>
+      </p:sp>
+      <p:sp>
+        <p:nvSpPr>
+          <p:cNvPr id="8" name="Text 6"/>
+          <p:cNvSpPr/>
+          <p:nvPr/>
+        </p:nvSpPr>
+        <p:spPr>
+          <a:xfrm>
+            <a:off x="731520" y="1289304"/>
+            <a:ext cx="5029200" cy="1481328"/>
           </a:xfrm>
           <a:prstGeom prst="rect">
             <a:avLst/>
@@ -5889,41 +6019,138 @@
               <a:buNone/>
             </a:pPr>
             <a:r>
-              <a:rPr lang="en-US" sz="1000" b="1" dirty="0">
-                <a:solidFill>
-                  <a:srgbClr val="FFFFFF"/>
-                </a:solidFill>
-              </a:rPr>
-              <a:t>구간</a:t>
-            </a:r>
-            <a:endParaRPr lang="en-US" sz="1000" dirty="0"/>
-          </a:p>
-        </p:txBody>
-      </p:sp>
-      <p:sp>
-        <p:nvSpPr>
-          <p:cNvPr id="8" name="Shape 6"/>
-          <p:cNvSpPr/>
-          <p:nvPr/>
-        </p:nvSpPr>
-        <p:spPr>
-          <a:xfrm>
-            <a:off x="1746504" y="868680"/>
-            <a:ext cx="2304288" cy="585216"/>
-          </a:xfrm>
-          <a:prstGeom prst="rect">
-            <a:avLst/>
-          </a:prstGeom>
-          <a:solidFill>
-            <a:srgbClr val="122033"/>
-          </a:solidFill>
-          <a:ln w="7620">
-            <a:solidFill>
-              <a:srgbClr val="D7DEEA"/>
-            </a:solidFill>
-            <a:prstDash val="solid"/>
-          </a:ln>
-        </p:spPr>
+              <a:rPr lang="en-US" sz="690" dirty="0">
+                <a:solidFill>
+                  <a:srgbClr val="E5E7EB"/>
+                </a:solidFill>
+                <a:latin typeface="Consolas" pitchFamily="34" charset="0"/>
+                <a:ea typeface="Consolas" pitchFamily="34" charset="-122"/>
+                <a:cs typeface="Consolas" pitchFamily="34" charset="-120"/>
+              </a:rPr>
+              <a:t>if ("GET".equals(method) &amp;&amp; "/api/state".equals(path)) {</a:t>
+            </a:r>
+            <a:endParaRPr lang="en-US" sz="690" dirty="0"/>
+          </a:p>
+          <a:p>
+            <a:pPr indent="0" marL="0">
+              <a:buNone/>
+            </a:pPr>
+            <a:r>
+              <a:rPr lang="en-US" sz="690" dirty="0">
+                <a:solidFill>
+                  <a:srgbClr val="E5E7EB"/>
+                </a:solidFill>
+                <a:latin typeface="Consolas" pitchFamily="34" charset="0"/>
+                <a:ea typeface="Consolas" pitchFamily="34" charset="-122"/>
+                <a:cs typeface="Consolas" pitchFamily="34" charset="-120"/>
+              </a:rPr>
+              <a:t>    send(exchange, 200, "application/json", project.stateJson());</a:t>
+            </a:r>
+            <a:endParaRPr lang="en-US" sz="690" dirty="0"/>
+          </a:p>
+          <a:p>
+            <a:pPr indent="0" marL="0">
+              <a:buNone/>
+            </a:pPr>
+            <a:r>
+              <a:rPr lang="en-US" sz="690" dirty="0">
+                <a:solidFill>
+                  <a:srgbClr val="E5E7EB"/>
+                </a:solidFill>
+                <a:latin typeface="Consolas" pitchFamily="34" charset="0"/>
+                <a:ea typeface="Consolas" pitchFamily="34" charset="-122"/>
+                <a:cs typeface="Consolas" pitchFamily="34" charset="-120"/>
+              </a:rPr>
+              <a:t>}</a:t>
+            </a:r>
+            <a:endParaRPr lang="en-US" sz="690" dirty="0"/>
+          </a:p>
+          <a:p>
+            <a:pPr indent="0" marL="0">
+              <a:buNone/>
+            </a:pPr>
+            <a:r>
+              <a:rPr lang="en-US" sz="690" dirty="0">
+                <a:solidFill>
+                  <a:srgbClr val="E5E7EB"/>
+                </a:solidFill>
+                <a:latin typeface="Consolas" pitchFamily="34" charset="0"/>
+                <a:ea typeface="Consolas" pitchFamily="34" charset="-122"/>
+                <a:cs typeface="Consolas" pitchFamily="34" charset="-120"/>
+              </a:rPr>
+              <a:t>String json = switch (path) {</a:t>
+            </a:r>
+            <a:endParaRPr lang="en-US" sz="690" dirty="0"/>
+          </a:p>
+          <a:p>
+            <a:pPr indent="0" marL="0">
+              <a:buNone/>
+            </a:pPr>
+            <a:r>
+              <a:rPr lang="en-US" sz="690" dirty="0">
+                <a:solidFill>
+                  <a:srgbClr val="E5E7EB"/>
+                </a:solidFill>
+                <a:latin typeface="Consolas" pitchFamily="34" charset="0"/>
+                <a:ea typeface="Consolas" pitchFamily="34" charset="-122"/>
+                <a:cs typeface="Consolas" pitchFamily="34" charset="-120"/>
+              </a:rPr>
+              <a:t>    case "/api/stock/buy" -&gt; project.buyStock(body);</a:t>
+            </a:r>
+            <a:endParaRPr lang="en-US" sz="690" dirty="0"/>
+          </a:p>
+          <a:p>
+            <a:pPr indent="0" marL="0">
+              <a:buNone/>
+            </a:pPr>
+            <a:r>
+              <a:rPr lang="en-US" sz="690" dirty="0">
+                <a:solidFill>
+                  <a:srgbClr val="E5E7EB"/>
+                </a:solidFill>
+                <a:latin typeface="Consolas" pitchFamily="34" charset="0"/>
+                <a:ea typeface="Consolas" pitchFamily="34" charset="-122"/>
+                <a:cs typeface="Consolas" pitchFamily="34" charset="-120"/>
+              </a:rPr>
+              <a:t>    case "/api/stock/sell" -&gt; project.sellStock(body);</a:t>
+            </a:r>
+            <a:endParaRPr lang="en-US" sz="690" dirty="0"/>
+          </a:p>
+          <a:p>
+            <a:pPr indent="0" marL="0">
+              <a:buNone/>
+            </a:pPr>
+            <a:r>
+              <a:rPr lang="en-US" sz="690" dirty="0">
+                <a:solidFill>
+                  <a:srgbClr val="E5E7EB"/>
+                </a:solidFill>
+                <a:latin typeface="Consolas" pitchFamily="34" charset="0"/>
+                <a:ea typeface="Consolas" pitchFamily="34" charset="-122"/>
+                <a:cs typeface="Consolas" pitchFamily="34" charset="-120"/>
+              </a:rPr>
+              <a:t>    default -&gt; Json.obj("ok", false, "error", "없는 API");</a:t>
+            </a:r>
+            <a:endParaRPr lang="en-US" sz="690" dirty="0"/>
+          </a:p>
+          <a:p>
+            <a:pPr indent="0" marL="0">
+              <a:buNone/>
+            </a:pPr>
+            <a:r>
+              <a:rPr lang="en-US" sz="690" dirty="0">
+                <a:solidFill>
+                  <a:srgbClr val="E5E7EB"/>
+                </a:solidFill>
+                <a:latin typeface="Consolas" pitchFamily="34" charset="0"/>
+                <a:ea typeface="Consolas" pitchFamily="34" charset="-122"/>
+                <a:cs typeface="Consolas" pitchFamily="34" charset="-120"/>
+              </a:rPr>
+              <a:t>};</a:t>
+            </a:r>
+            <a:endParaRPr lang="en-US" sz="690" dirty="0"/>
+          </a:p>
+        </p:txBody>
       </p:sp>
       <p:sp>
         <p:nvSpPr>
@@ -5933,8 +6160,74 @@
         </p:nvSpPr>
         <p:spPr>
           <a:xfrm>
-            <a:off x="1819656" y="941832"/>
-            <a:ext cx="2157984" cy="457200"/>
+            <a:off x="6217920" y="868680"/>
+            <a:ext cx="5349240" cy="219456"/>
+          </a:xfrm>
+          <a:prstGeom prst="rect">
+            <a:avLst/>
+          </a:prstGeom>
+          <a:noFill/>
+          <a:ln/>
+        </p:spPr>
+        <p:txBody>
+          <a:bodyPr wrap="square" lIns="0" tIns="0" rIns="0" bIns="0" rtlCol="0" anchor="ctr"/>
+          <a:lstStyle/>
+          <a:p>
+            <a:pPr indent="0" marL="0">
+              <a:buNone/>
+            </a:pPr>
+            <a:r>
+              <a:rPr lang="en-US" sz="1050" b="1" dirty="0">
+                <a:solidFill>
+                  <a:srgbClr val="1F5FBF"/>
+                </a:solidFill>
+                <a:latin typeface="Malgun Gothic" pitchFamily="34" charset="0"/>
+                <a:ea typeface="Malgun Gothic" pitchFamily="34" charset="-122"/>
+                <a:cs typeface="Malgun Gothic" pitchFamily="34" charset="-120"/>
+              </a:rPr>
+              <a:t>KIS 현재가 조회 - KisIntegration.java</a:t>
+            </a:r>
+            <a:endParaRPr lang="en-US" sz="1050" dirty="0"/>
+          </a:p>
+        </p:txBody>
+      </p:sp>
+      <p:sp>
+        <p:nvSpPr>
+          <p:cNvPr id="10" name="Shape 8"/>
+          <p:cNvSpPr/>
+          <p:nvPr/>
+        </p:nvSpPr>
+        <p:spPr>
+          <a:xfrm>
+            <a:off x="6217920" y="1161288"/>
+            <a:ext cx="5349240" cy="1719072"/>
+          </a:xfrm>
+          <a:prstGeom prst="roundRect">
+            <a:avLst>
+              <a:gd name="adj" fmla="val 2128"/>
+            </a:avLst>
+          </a:prstGeom>
+          <a:solidFill>
+            <a:srgbClr val="111827"/>
+          </a:solidFill>
+          <a:ln w="10160">
+            <a:solidFill>
+              <a:srgbClr val="334155"/>
+            </a:solidFill>
+            <a:prstDash val="solid"/>
+          </a:ln>
+        </p:spPr>
+      </p:sp>
+      <p:sp>
+        <p:nvSpPr>
+          <p:cNvPr id="11" name="Text 9"/>
+          <p:cNvSpPr/>
+          <p:nvPr/>
+        </p:nvSpPr>
+        <p:spPr>
+          <a:xfrm>
+            <a:off x="6355080" y="1289304"/>
+            <a:ext cx="5074920" cy="1481328"/>
           </a:xfrm>
           <a:prstGeom prst="rect">
             <a:avLst/>
@@ -5952,52 +6245,198 @@
               <a:buNone/>
             </a:pPr>
             <a:r>
-              <a:rPr lang="en-US" sz="1000" b="1" dirty="0">
-                <a:solidFill>
-                  <a:srgbClr val="FFFFFF"/>
-                </a:solidFill>
-              </a:rPr>
-              <a:t>보여줄 화면</a:t>
-            </a:r>
-            <a:endParaRPr lang="en-US" sz="1000" dirty="0"/>
-          </a:p>
-        </p:txBody>
-      </p:sp>
-      <p:sp>
-        <p:nvSpPr>
-          <p:cNvPr id="10" name="Shape 8"/>
-          <p:cNvSpPr/>
-          <p:nvPr/>
-        </p:nvSpPr>
-        <p:spPr>
-          <a:xfrm>
-            <a:off x="4050792" y="868680"/>
-            <a:ext cx="2944368" cy="585216"/>
-          </a:xfrm>
-          <a:prstGeom prst="rect">
-            <a:avLst/>
-          </a:prstGeom>
-          <a:solidFill>
-            <a:srgbClr val="122033"/>
-          </a:solidFill>
-          <a:ln w="7620">
-            <a:solidFill>
-              <a:srgbClr val="D7DEEA"/>
-            </a:solidFill>
-            <a:prstDash val="solid"/>
-          </a:ln>
-        </p:spPr>
-      </p:sp>
-      <p:sp>
-        <p:nvSpPr>
-          <p:cNvPr id="11" name="Text 9"/>
-          <p:cNvSpPr/>
-          <p:nvPr/>
-        </p:nvSpPr>
-        <p:spPr>
-          <a:xfrm>
-            <a:off x="4123944" y="941832"/>
-            <a:ext cx="2798064" cy="457200"/>
+              <a:rPr lang="en-US" sz="690" dirty="0">
+                <a:solidFill>
+                  <a:srgbClr val="E5E7EB"/>
+                </a:solidFill>
+                <a:latin typeface="Consolas" pitchFamily="34" charset="0"/>
+                <a:ea typeface="Consolas" pitchFamily="34" charset="-122"/>
+                <a:cs typeface="Consolas" pitchFamily="34" charset="-120"/>
+              </a:rPr>
+              <a:t>HttpRequest request = HttpRequest.newBuilder(uri)</a:t>
+            </a:r>
+            <a:endParaRPr lang="en-US" sz="690" dirty="0"/>
+          </a:p>
+          <a:p>
+            <a:pPr indent="0" marL="0">
+              <a:buNone/>
+            </a:pPr>
+            <a:r>
+              <a:rPr lang="en-US" sz="690" dirty="0">
+                <a:solidFill>
+                  <a:srgbClr val="E5E7EB"/>
+                </a:solidFill>
+                <a:latin typeface="Consolas" pitchFamily="34" charset="0"/>
+                <a:ea typeface="Consolas" pitchFamily="34" charset="-122"/>
+                <a:cs typeface="Consolas" pitchFamily="34" charset="-120"/>
+              </a:rPr>
+              <a:t>    .header("authorization", "Bearer " + token)</a:t>
+            </a:r>
+            <a:endParaRPr lang="en-US" sz="690" dirty="0"/>
+          </a:p>
+          <a:p>
+            <a:pPr indent="0" marL="0">
+              <a:buNone/>
+            </a:pPr>
+            <a:r>
+              <a:rPr lang="en-US" sz="690" dirty="0">
+                <a:solidFill>
+                  <a:srgbClr val="E5E7EB"/>
+                </a:solidFill>
+                <a:latin typeface="Consolas" pitchFamily="34" charset="0"/>
+                <a:ea typeface="Consolas" pitchFamily="34" charset="-122"/>
+                <a:cs typeface="Consolas" pitchFamily="34" charset="-120"/>
+              </a:rPr>
+              <a:t>    .header("appkey", config.appKey)</a:t>
+            </a:r>
+            <a:endParaRPr lang="en-US" sz="690" dirty="0"/>
+          </a:p>
+          <a:p>
+            <a:pPr indent="0" marL="0">
+              <a:buNone/>
+            </a:pPr>
+            <a:r>
+              <a:rPr lang="en-US" sz="690" dirty="0">
+                <a:solidFill>
+                  <a:srgbClr val="E5E7EB"/>
+                </a:solidFill>
+                <a:latin typeface="Consolas" pitchFamily="34" charset="0"/>
+                <a:ea typeface="Consolas" pitchFamily="34" charset="-122"/>
+                <a:cs typeface="Consolas" pitchFamily="34" charset="-120"/>
+              </a:rPr>
+              <a:t>    .header("tr_id", "FHKST01010100")</a:t>
+            </a:r>
+            <a:endParaRPr lang="en-US" sz="690" dirty="0"/>
+          </a:p>
+          <a:p>
+            <a:pPr indent="0" marL="0">
+              <a:buNone/>
+            </a:pPr>
+            <a:r>
+              <a:rPr lang="en-US" sz="690" dirty="0">
+                <a:solidFill>
+                  <a:srgbClr val="E5E7EB"/>
+                </a:solidFill>
+                <a:latin typeface="Consolas" pitchFamily="34" charset="0"/>
+                <a:ea typeface="Consolas" pitchFamily="34" charset="-122"/>
+                <a:cs typeface="Consolas" pitchFamily="34" charset="-120"/>
+              </a:rPr>
+              <a:t>    .GET()</a:t>
+            </a:r>
+            <a:endParaRPr lang="en-US" sz="690" dirty="0"/>
+          </a:p>
+          <a:p>
+            <a:pPr indent="0" marL="0">
+              <a:buNone/>
+            </a:pPr>
+            <a:r>
+              <a:rPr lang="en-US" sz="690" dirty="0">
+                <a:solidFill>
+                  <a:srgbClr val="E5E7EB"/>
+                </a:solidFill>
+                <a:latin typeface="Consolas" pitchFamily="34" charset="0"/>
+                <a:ea typeface="Consolas" pitchFamily="34" charset="-122"/>
+                <a:cs typeface="Consolas" pitchFamily="34" charset="-120"/>
+              </a:rPr>
+              <a:t>    .build();</a:t>
+            </a:r>
+            <a:endParaRPr lang="en-US" sz="690" dirty="0"/>
+          </a:p>
+          <a:p>
+            <a:pPr indent="0" marL="0">
+              <a:buNone/>
+            </a:pPr>
+            <a:r>
+              <a:rPr lang="en-US" sz="690" dirty="0">
+                <a:solidFill>
+                  <a:srgbClr val="E5E7EB"/>
+                </a:solidFill>
+                <a:latin typeface="Consolas" pitchFamily="34" charset="0"/>
+                <a:ea typeface="Consolas" pitchFamily="34" charset="-122"/>
+                <a:cs typeface="Consolas" pitchFamily="34" charset="-120"/>
+              </a:rPr>
+              <a:t>HttpResponse&lt;String&gt; response = client.send(request, BodyHandlers.ofString());</a:t>
+            </a:r>
+            <a:endParaRPr lang="en-US" sz="690" dirty="0"/>
+          </a:p>
+        </p:txBody>
+      </p:sp>
+      <p:sp>
+        <p:nvSpPr>
+          <p:cNvPr id="12" name="Text 10"/>
+          <p:cNvSpPr/>
+          <p:nvPr/>
+        </p:nvSpPr>
+        <p:spPr>
+          <a:xfrm>
+            <a:off x="594360" y="3246120"/>
+            <a:ext cx="5303520" cy="219456"/>
+          </a:xfrm>
+          <a:prstGeom prst="rect">
+            <a:avLst/>
+          </a:prstGeom>
+          <a:noFill/>
+          <a:ln/>
+        </p:spPr>
+        <p:txBody>
+          <a:bodyPr wrap="square" lIns="0" tIns="0" rIns="0" bIns="0" rtlCol="0" anchor="ctr"/>
+          <a:lstStyle/>
+          <a:p>
+            <a:pPr indent="0" marL="0">
+              <a:buNone/>
+            </a:pPr>
+            <a:r>
+              <a:rPr lang="en-US" sz="1050" b="1" dirty="0">
+                <a:solidFill>
+                  <a:srgbClr val="1F5FBF"/>
+                </a:solidFill>
+                <a:latin typeface="Malgun Gothic" pitchFamily="34" charset="0"/>
+                <a:ea typeface="Malgun Gothic" pitchFamily="34" charset="-122"/>
+                <a:cs typeface="Malgun Gothic" pitchFamily="34" charset="-120"/>
+              </a:rPr>
+              <a:t>매수 처리 - MiniProject.java</a:t>
+            </a:r>
+            <a:endParaRPr lang="en-US" sz="1050" dirty="0"/>
+          </a:p>
+        </p:txBody>
+      </p:sp>
+      <p:sp>
+        <p:nvSpPr>
+          <p:cNvPr id="13" name="Shape 11"/>
+          <p:cNvSpPr/>
+          <p:nvPr/>
+        </p:nvSpPr>
+        <p:spPr>
+          <a:xfrm>
+            <a:off x="594360" y="3538728"/>
+            <a:ext cx="5303520" cy="1947672"/>
+          </a:xfrm>
+          <a:prstGeom prst="roundRect">
+            <a:avLst>
+              <a:gd name="adj" fmla="val 1878"/>
+            </a:avLst>
+          </a:prstGeom>
+          <a:solidFill>
+            <a:srgbClr val="111827"/>
+          </a:solidFill>
+          <a:ln w="10160">
+            <a:solidFill>
+              <a:srgbClr val="334155"/>
+            </a:solidFill>
+            <a:prstDash val="solid"/>
+          </a:ln>
+        </p:spPr>
+      </p:sp>
+      <p:sp>
+        <p:nvSpPr>
+          <p:cNvPr id="14" name="Text 12"/>
+          <p:cNvSpPr/>
+          <p:nvPr/>
+        </p:nvSpPr>
+        <p:spPr>
+          <a:xfrm>
+            <a:off x="731520" y="3666744"/>
+            <a:ext cx="5029200" cy="1709928"/>
           </a:xfrm>
           <a:prstGeom prst="rect">
             <a:avLst/>
@@ -6015,52 +6454,198 @@
               <a:buNone/>
             </a:pPr>
             <a:r>
-              <a:rPr lang="en-US" sz="1000" b="1" dirty="0">
-                <a:solidFill>
-                  <a:srgbClr val="FFFFFF"/>
-                </a:solidFill>
-              </a:rPr>
-              <a:t>말할 내용</a:t>
-            </a:r>
-            <a:endParaRPr lang="en-US" sz="1000" dirty="0"/>
-          </a:p>
-        </p:txBody>
-      </p:sp>
-      <p:sp>
-        <p:nvSpPr>
-          <p:cNvPr id="12" name="Shape 10"/>
-          <p:cNvSpPr/>
-          <p:nvPr/>
-        </p:nvSpPr>
-        <p:spPr>
-          <a:xfrm>
-            <a:off x="594360" y="1453896"/>
-            <a:ext cx="1152144" cy="585216"/>
-          </a:xfrm>
-          <a:prstGeom prst="rect">
-            <a:avLst/>
-          </a:prstGeom>
-          <a:solidFill>
-            <a:srgbClr val="FFFFFF"/>
-          </a:solidFill>
-          <a:ln w="7620">
-            <a:solidFill>
-              <a:srgbClr val="D7DEEA"/>
-            </a:solidFill>
-            <a:prstDash val="solid"/>
-          </a:ln>
-        </p:spPr>
-      </p:sp>
-      <p:sp>
-        <p:nvSpPr>
-          <p:cNvPr id="13" name="Text 11"/>
-          <p:cNvSpPr/>
-          <p:nvPr/>
-        </p:nvSpPr>
-        <p:spPr>
-          <a:xfrm>
-            <a:off x="667512" y="1527048"/>
-            <a:ext cx="1005840" cy="457200"/>
+              <a:rPr lang="en-US" sz="690" dirty="0">
+                <a:solidFill>
+                  <a:srgbClr val="E5E7EB"/>
+                </a:solidFill>
+                <a:latin typeface="Consolas" pitchFamily="34" charset="0"/>
+                <a:ea typeface="Consolas" pitchFamily="34" charset="-122"/>
+                <a:cs typeface="Consolas" pitchFamily="34" charset="-120"/>
+              </a:rPr>
+              <a:t>Stock stock = findStock(stockName);</a:t>
+            </a:r>
+            <a:endParaRPr lang="en-US" sz="690" dirty="0"/>
+          </a:p>
+          <a:p>
+            <a:pPr indent="0" marL="0">
+              <a:buNone/>
+            </a:pPr>
+            <a:r>
+              <a:rPr lang="en-US" sz="690" dirty="0">
+                <a:solidFill>
+                  <a:srgbClr val="E5E7EB"/>
+                </a:solidFill>
+                <a:latin typeface="Consolas" pitchFamily="34" charset="0"/>
+                <a:ea typeface="Consolas" pitchFamily="34" charset="-122"/>
+                <a:cs typeface="Consolas" pitchFamily="34" charset="-120"/>
+              </a:rPr>
+              <a:t>long total = (long) stock.price * quantity;</a:t>
+            </a:r>
+            <a:endParaRPr lang="en-US" sz="690" dirty="0"/>
+          </a:p>
+          <a:p>
+            <a:pPr indent="0" marL="0">
+              <a:buNone/>
+            </a:pPr>
+            <a:r>
+              <a:rPr lang="en-US" sz="690" dirty="0">
+                <a:solidFill>
+                  <a:srgbClr val="E5E7EB"/>
+                </a:solidFill>
+                <a:latin typeface="Consolas" pitchFamily="34" charset="0"/>
+                <a:ea typeface="Consolas" pitchFamily="34" charset="-122"/>
+                <a:cs typeface="Consolas" pitchFamily="34" charset="-120"/>
+              </a:rPr>
+              <a:t>if (currentMember.balance &lt; total) return Json.obj("ok", false);</a:t>
+            </a:r>
+            <a:endParaRPr lang="en-US" sz="690" dirty="0"/>
+          </a:p>
+          <a:p>
+            <a:pPr indent="0" marL="0">
+              <a:buNone/>
+            </a:pPr>
+            <a:r>
+              <a:rPr lang="en-US" sz="690" dirty="0">
+                <a:solidFill>
+                  <a:srgbClr val="E5E7EB"/>
+                </a:solidFill>
+                <a:latin typeface="Consolas" pitchFamily="34" charset="0"/>
+                <a:ea typeface="Consolas" pitchFamily="34" charset="-122"/>
+                <a:cs typeface="Consolas" pitchFamily="34" charset="-120"/>
+              </a:rPr>
+              <a:t>currentMember.balance -= total;</a:t>
+            </a:r>
+            <a:endParaRPr lang="en-US" sz="690" dirty="0"/>
+          </a:p>
+          <a:p>
+            <a:pPr indent="0" marL="0">
+              <a:buNone/>
+            </a:pPr>
+            <a:r>
+              <a:rPr lang="en-US" sz="690" dirty="0">
+                <a:solidFill>
+                  <a:srgbClr val="E5E7EB"/>
+                </a:solidFill>
+                <a:latin typeface="Consolas" pitchFamily="34" charset="0"/>
+                <a:ea typeface="Consolas" pitchFamily="34" charset="-122"/>
+                <a:cs typeface="Consolas" pitchFamily="34" charset="-120"/>
+              </a:rPr>
+              <a:t>currentMember.shares.put(stockName, share.buy(quantity, total));</a:t>
+            </a:r>
+            <a:endParaRPr lang="en-US" sz="690" dirty="0"/>
+          </a:p>
+          <a:p>
+            <a:pPr indent="0" marL="0">
+              <a:buNone/>
+            </a:pPr>
+            <a:r>
+              <a:rPr lang="en-US" sz="690" dirty="0">
+                <a:solidFill>
+                  <a:srgbClr val="E5E7EB"/>
+                </a:solidFill>
+                <a:latin typeface="Consolas" pitchFamily="34" charset="0"/>
+                <a:ea typeface="Consolas" pitchFamily="34" charset="-122"/>
+                <a:cs typeface="Consolas" pitchFamily="34" charset="-120"/>
+              </a:rPr>
+              <a:t>logs.add(new TradeLog(currentMember.uid, stockName, quantity, total, "구매"));</a:t>
+            </a:r>
+            <a:endParaRPr lang="en-US" sz="690" dirty="0"/>
+          </a:p>
+          <a:p>
+            <a:pPr indent="0" marL="0">
+              <a:buNone/>
+            </a:pPr>
+            <a:r>
+              <a:rPr lang="en-US" sz="690" dirty="0">
+                <a:solidFill>
+                  <a:srgbClr val="E5E7EB"/>
+                </a:solidFill>
+                <a:latin typeface="Consolas" pitchFamily="34" charset="0"/>
+                <a:ea typeface="Consolas" pitchFamily="34" charset="-122"/>
+                <a:cs typeface="Consolas" pitchFamily="34" charset="-120"/>
+              </a:rPr>
+              <a:t>saveDatabase();</a:t>
+            </a:r>
+            <a:endParaRPr lang="en-US" sz="690" dirty="0"/>
+          </a:p>
+        </p:txBody>
+      </p:sp>
+      <p:sp>
+        <p:nvSpPr>
+          <p:cNvPr id="15" name="Text 13"/>
+          <p:cNvSpPr/>
+          <p:nvPr/>
+        </p:nvSpPr>
+        <p:spPr>
+          <a:xfrm>
+            <a:off x="6217920" y="3246120"/>
+            <a:ext cx="5349240" cy="219456"/>
+          </a:xfrm>
+          <a:prstGeom prst="rect">
+            <a:avLst/>
+          </a:prstGeom>
+          <a:noFill/>
+          <a:ln/>
+        </p:spPr>
+        <p:txBody>
+          <a:bodyPr wrap="square" lIns="0" tIns="0" rIns="0" bIns="0" rtlCol="0" anchor="ctr"/>
+          <a:lstStyle/>
+          <a:p>
+            <a:pPr indent="0" marL="0">
+              <a:buNone/>
+            </a:pPr>
+            <a:r>
+              <a:rPr lang="en-US" sz="1050" b="1" dirty="0">
+                <a:solidFill>
+                  <a:srgbClr val="1F5FBF"/>
+                </a:solidFill>
+                <a:latin typeface="Malgun Gothic" pitchFamily="34" charset="0"/>
+                <a:ea typeface="Malgun Gothic" pitchFamily="34" charset="-122"/>
+                <a:cs typeface="Malgun Gothic" pitchFamily="34" charset="-120"/>
+              </a:rPr>
+              <a:t>MySQL 저장 - DatabaseIntegration.java</a:t>
+            </a:r>
+            <a:endParaRPr lang="en-US" sz="1050" dirty="0"/>
+          </a:p>
+        </p:txBody>
+      </p:sp>
+      <p:sp>
+        <p:nvSpPr>
+          <p:cNvPr id="16" name="Shape 14"/>
+          <p:cNvSpPr/>
+          <p:nvPr/>
+        </p:nvSpPr>
+        <p:spPr>
+          <a:xfrm>
+            <a:off x="6217920" y="3538728"/>
+            <a:ext cx="5349240" cy="1947672"/>
+          </a:xfrm>
+          <a:prstGeom prst="roundRect">
+            <a:avLst>
+              <a:gd name="adj" fmla="val 1878"/>
+            </a:avLst>
+          </a:prstGeom>
+          <a:solidFill>
+            <a:srgbClr val="111827"/>
+          </a:solidFill>
+          <a:ln w="10160">
+            <a:solidFill>
+              <a:srgbClr val="334155"/>
+            </a:solidFill>
+            <a:prstDash val="solid"/>
+          </a:ln>
+        </p:spPr>
+      </p:sp>
+      <p:sp>
+        <p:nvSpPr>
+          <p:cNvPr id="17" name="Text 15"/>
+          <p:cNvSpPr/>
+          <p:nvPr/>
+        </p:nvSpPr>
+        <p:spPr>
+          <a:xfrm>
+            <a:off x="6355080" y="3666744"/>
+            <a:ext cx="5074920" cy="1709928"/>
           </a:xfrm>
           <a:prstGeom prst="rect">
             <a:avLst/>
@@ -6078,33 +6663,336 @@
               <a:buNone/>
             </a:pPr>
             <a:r>
-              <a:rPr lang="en-US" sz="920" dirty="0">
+              <a:rPr lang="en-US" sz="690" dirty="0">
+                <a:solidFill>
+                  <a:srgbClr val="E5E7EB"/>
+                </a:solidFill>
+                <a:latin typeface="Consolas" pitchFamily="34" charset="0"/>
+                <a:ea typeface="Consolas" pitchFamily="34" charset="-122"/>
+                <a:cs typeface="Consolas" pitchFamily="34" charset="-120"/>
+              </a:rPr>
+              <a:t>try (Connection con = DriverManager.getConnection(url, user, password)) {</a:t>
+            </a:r>
+            <a:endParaRPr lang="en-US" sz="690" dirty="0"/>
+          </a:p>
+          <a:p>
+            <a:pPr indent="0" marL="0">
+              <a:buNone/>
+            </a:pPr>
+            <a:r>
+              <a:rPr lang="en-US" sz="690" dirty="0">
+                <a:solidFill>
+                  <a:srgbClr val="E5E7EB"/>
+                </a:solidFill>
+                <a:latin typeface="Consolas" pitchFamily="34" charset="0"/>
+                <a:ea typeface="Consolas" pitchFamily="34" charset="-122"/>
+                <a:cs typeface="Consolas" pitchFamily="34" charset="-120"/>
+              </a:rPr>
+              <a:t>    con.setAutoCommit(false);</a:t>
+            </a:r>
+            <a:endParaRPr lang="en-US" sz="690" dirty="0"/>
+          </a:p>
+          <a:p>
+            <a:pPr indent="0" marL="0">
+              <a:buNone/>
+            </a:pPr>
+            <a:r>
+              <a:rPr lang="en-US" sz="690" dirty="0">
+                <a:solidFill>
+                  <a:srgbClr val="E5E7EB"/>
+                </a:solidFill>
+                <a:latin typeface="Consolas" pitchFamily="34" charset="0"/>
+                <a:ea typeface="Consolas" pitchFamily="34" charset="-122"/>
+                <a:cs typeface="Consolas" pitchFamily="34" charset="-120"/>
+              </a:rPr>
+              <a:t>    insertMembers(con, members);</a:t>
+            </a:r>
+            <a:endParaRPr lang="en-US" sz="690" dirty="0"/>
+          </a:p>
+          <a:p>
+            <a:pPr indent="0" marL="0">
+              <a:buNone/>
+            </a:pPr>
+            <a:r>
+              <a:rPr lang="en-US" sz="690" dirty="0">
+                <a:solidFill>
+                  <a:srgbClr val="E5E7EB"/>
+                </a:solidFill>
+                <a:latin typeface="Consolas" pitchFamily="34" charset="0"/>
+                <a:ea typeface="Consolas" pitchFamily="34" charset="-122"/>
+                <a:cs typeface="Consolas" pitchFamily="34" charset="-120"/>
+              </a:rPr>
+              <a:t>    insertShares(con, members);</a:t>
+            </a:r>
+            <a:endParaRPr lang="en-US" sz="690" dirty="0"/>
+          </a:p>
+          <a:p>
+            <a:pPr indent="0" marL="0">
+              <a:buNone/>
+            </a:pPr>
+            <a:r>
+              <a:rPr lang="en-US" sz="690" dirty="0">
+                <a:solidFill>
+                  <a:srgbClr val="E5E7EB"/>
+                </a:solidFill>
+                <a:latin typeface="Consolas" pitchFamily="34" charset="0"/>
+                <a:ea typeface="Consolas" pitchFamily="34" charset="-122"/>
+                <a:cs typeface="Consolas" pitchFamily="34" charset="-120"/>
+              </a:rPr>
+              <a:t>    insertTradeLogs(con, logs);</a:t>
+            </a:r>
+            <a:endParaRPr lang="en-US" sz="690" dirty="0"/>
+          </a:p>
+          <a:p>
+            <a:pPr indent="0" marL="0">
+              <a:buNone/>
+            </a:pPr>
+            <a:r>
+              <a:rPr lang="en-US" sz="690" dirty="0">
+                <a:solidFill>
+                  <a:srgbClr val="E5E7EB"/>
+                </a:solidFill>
+                <a:latin typeface="Consolas" pitchFamily="34" charset="0"/>
+                <a:ea typeface="Consolas" pitchFamily="34" charset="-122"/>
+                <a:cs typeface="Consolas" pitchFamily="34" charset="-120"/>
+              </a:rPr>
+              <a:t>    con.commit();</a:t>
+            </a:r>
+            <a:endParaRPr lang="en-US" sz="690" dirty="0"/>
+          </a:p>
+          <a:p>
+            <a:pPr indent="0" marL="0">
+              <a:buNone/>
+            </a:pPr>
+            <a:r>
+              <a:rPr lang="en-US" sz="690" dirty="0">
+                <a:solidFill>
+                  <a:srgbClr val="E5E7EB"/>
+                </a:solidFill>
+                <a:latin typeface="Consolas" pitchFamily="34" charset="0"/>
+                <a:ea typeface="Consolas" pitchFamily="34" charset="-122"/>
+                <a:cs typeface="Consolas" pitchFamily="34" charset="-120"/>
+              </a:rPr>
+              <a:t>}</a:t>
+            </a:r>
+            <a:endParaRPr lang="en-US" sz="690" dirty="0"/>
+          </a:p>
+        </p:txBody>
+      </p:sp>
+      <p:sp>
+        <p:nvSpPr>
+          <p:cNvPr id="18" name="Text 16"/>
+          <p:cNvSpPr/>
+          <p:nvPr/>
+        </p:nvSpPr>
+        <p:spPr>
+          <a:xfrm>
+            <a:off x="685800" y="5760720"/>
+            <a:ext cx="10881360" cy="274320"/>
+          </a:xfrm>
+          <a:prstGeom prst="rect">
+            <a:avLst/>
+          </a:prstGeom>
+          <a:noFill/>
+          <a:ln/>
+        </p:spPr>
+        <p:txBody>
+          <a:bodyPr wrap="square" lIns="0" tIns="0" rIns="0" bIns="0" rtlCol="0" anchor="ctr"/>
+          <a:lstStyle/>
+          <a:p>
+            <a:pPr indent="0" marL="0">
+              <a:buNone/>
+            </a:pPr>
+            <a:r>
+              <a:rPr lang="en-US" sz="1250" b="1" dirty="0">
                 <a:solidFill>
                   <a:srgbClr val="182230"/>
                 </a:solidFill>
               </a:rPr>
-              <a:t>0~10초</a:t>
-            </a:r>
-            <a:endParaRPr lang="en-US" sz="920" dirty="0"/>
-          </a:p>
-        </p:txBody>
-      </p:sp>
-      <p:sp>
-        <p:nvSpPr>
-          <p:cNvPr id="14" name="Shape 12"/>
-          <p:cNvSpPr/>
-          <p:nvPr/>
-        </p:nvSpPr>
-        <p:spPr>
-          <a:xfrm>
-            <a:off x="1746504" y="1453896"/>
-            <a:ext cx="2304288" cy="585216"/>
-          </a:xfrm>
-          <a:prstGeom prst="rect">
-            <a:avLst/>
-          </a:prstGeom>
-          <a:solidFill>
-            <a:srgbClr val="FFFFFF"/>
+              <a:t>발표에서는 전체 코드를 읽기보다 요청 처리, 외부 API, 거래 처리, 저장 흐름이 실제로 연결되어 있다는 점을 보여준다.</a:t>
+            </a:r>
+            <a:endParaRPr lang="en-US" sz="1250" dirty="0"/>
+          </a:p>
+        </p:txBody>
+      </p:sp>
+    </p:spTree>
+  </p:cSld>
+  <p:clrMapOvr>
+    <a:masterClrMapping/>
+  </p:clrMapOvr>
+</p:sld>
+</file>
+
+<file path=ppt/slides/slide15.xml><?xml version="1.0" encoding="utf-8"?>
+<p:sld xmlns:a="http://schemas.openxmlformats.org/drawingml/2006/main" xmlns:r="http://schemas.openxmlformats.org/officeDocument/2006/relationships" xmlns:p="http://schemas.openxmlformats.org/presentationml/2006/main">
+  <p:cSld name="Slide 15">
+    <p:spTree>
+      <p:nvGrpSpPr>
+        <p:cNvPr id="1" name=""/>
+        <p:cNvGrpSpPr/>
+        <p:nvPr/>
+      </p:nvGrpSpPr>
+      <p:grpSpPr>
+        <a:xfrm>
+          <a:off x="0" y="0"/>
+          <a:ext cx="0" cy="0"/>
+          <a:chOff x="0" y="0"/>
+          <a:chExt cx="0" cy="0"/>
+        </a:xfrm>
+      </p:grpSpPr>
+      <p:sp>
+        <p:nvSpPr>
+          <p:cNvPr id="2" name="Text 0"/>
+          <p:cNvSpPr/>
+          <p:nvPr/>
+        </p:nvSpPr>
+        <p:spPr>
+          <a:xfrm>
+            <a:off x="320040" y="182880"/>
+            <a:ext cx="411480" cy="228600"/>
+          </a:xfrm>
+          <a:prstGeom prst="rect">
+            <a:avLst/>
+          </a:prstGeom>
+          <a:noFill/>
+          <a:ln/>
+        </p:spPr>
+        <p:txBody>
+          <a:bodyPr wrap="square" lIns="0" tIns="0" rIns="0" bIns="0" rtlCol="0" anchor="ctr"/>
+          <a:lstStyle/>
+          <a:p>
+            <a:pPr indent="0" marL="0">
+              <a:buNone/>
+            </a:pPr>
+            <a:r>
+              <a:rPr lang="en-US" sz="800" b="1" dirty="0">
+                <a:solidFill>
+                  <a:srgbClr val="1F5FBF"/>
+                </a:solidFill>
+                <a:latin typeface="Malgun Gothic" pitchFamily="34" charset="0"/>
+                <a:ea typeface="Malgun Gothic" pitchFamily="34" charset="-122"/>
+                <a:cs typeface="Malgun Gothic" pitchFamily="34" charset="-120"/>
+              </a:rPr>
+              <a:t>15</a:t>
+            </a:r>
+            <a:endParaRPr lang="en-US" sz="800" dirty="0"/>
+          </a:p>
+        </p:txBody>
+      </p:sp>
+      <p:sp>
+        <p:nvSpPr>
+          <p:cNvPr id="3" name="Text 1"/>
+          <p:cNvSpPr/>
+          <p:nvPr/>
+        </p:nvSpPr>
+        <p:spPr>
+          <a:xfrm>
+            <a:off x="822960" y="137160"/>
+            <a:ext cx="8961120" cy="320040"/>
+          </a:xfrm>
+          <a:prstGeom prst="rect">
+            <a:avLst/>
+          </a:prstGeom>
+          <a:noFill/>
+          <a:ln/>
+        </p:spPr>
+        <p:txBody>
+          <a:bodyPr wrap="square" lIns="0" tIns="0" rIns="0" bIns="0" rtlCol="0" anchor="ctr"/>
+          <a:lstStyle/>
+          <a:p>
+            <a:pPr indent="0" marL="0">
+              <a:buNone/>
+            </a:pPr>
+            <a:r>
+              <a:rPr lang="en-US" sz="1600" b="1" dirty="0">
+                <a:solidFill>
+                  <a:srgbClr val="182230"/>
+                </a:solidFill>
+                <a:latin typeface="Malgun Gothic" pitchFamily="34" charset="0"/>
+                <a:ea typeface="Malgun Gothic" pitchFamily="34" charset="-122"/>
+                <a:cs typeface="Malgun Gothic" pitchFamily="34" charset="-120"/>
+              </a:rPr>
+              <a:t>시연 영상 구성</a:t>
+            </a:r>
+            <a:endParaRPr lang="en-US" sz="1600" dirty="0"/>
+          </a:p>
+        </p:txBody>
+      </p:sp>
+      <p:sp>
+        <p:nvSpPr>
+          <p:cNvPr id="4" name="Shape 2"/>
+          <p:cNvSpPr/>
+          <p:nvPr/>
+        </p:nvSpPr>
+        <p:spPr>
+          <a:xfrm>
+            <a:off x="320040" y="594360"/>
+            <a:ext cx="11521440" cy="0"/>
+          </a:xfrm>
+          <a:prstGeom prst="line">
+            <a:avLst/>
+          </a:prstGeom>
+          <a:noFill/>
+          <a:ln w="12700">
+            <a:solidFill>
+              <a:srgbClr val="D7DEEA"/>
+            </a:solidFill>
+            <a:prstDash val="solid"/>
+          </a:ln>
+        </p:spPr>
+      </p:sp>
+      <p:sp>
+        <p:nvSpPr>
+          <p:cNvPr id="5" name="Text 3"/>
+          <p:cNvSpPr/>
+          <p:nvPr/>
+        </p:nvSpPr>
+        <p:spPr>
+          <a:xfrm>
+            <a:off x="411480" y="6547104"/>
+            <a:ext cx="7680960" cy="146304"/>
+          </a:xfrm>
+          <a:prstGeom prst="rect">
+            <a:avLst/>
+          </a:prstGeom>
+          <a:noFill/>
+          <a:ln/>
+        </p:spPr>
+        <p:txBody>
+          <a:bodyPr wrap="square" lIns="0" tIns="0" rIns="0" bIns="0" rtlCol="0" anchor="ctr"/>
+          <a:lstStyle/>
+          <a:p>
+            <a:pPr indent="0" marL="0">
+              <a:buNone/>
+            </a:pPr>
+            <a:r>
+              <a:rPr lang="en-US" sz="750" dirty="0">
+                <a:solidFill>
+                  <a:srgbClr val="7A8797"/>
+                </a:solidFill>
+              </a:rPr>
+              <a:t>Java 프로젝트 모의주식 | KIS Open API · MySQL · 소켓 기반 모의투자 웹앱</a:t>
+            </a:r>
+            <a:endParaRPr lang="en-US" sz="750" dirty="0"/>
+          </a:p>
+        </p:txBody>
+      </p:sp>
+      <p:sp>
+        <p:nvSpPr>
+          <p:cNvPr id="6" name="Shape 4"/>
+          <p:cNvSpPr/>
+          <p:nvPr/>
+        </p:nvSpPr>
+        <p:spPr>
+          <a:xfrm>
+            <a:off x="594360" y="868680"/>
+            <a:ext cx="1152144" cy="585216"/>
+          </a:xfrm>
+          <a:prstGeom prst="rect">
+            <a:avLst/>
+          </a:prstGeom>
+          <a:solidFill>
+            <a:srgbClr val="122033"/>
           </a:solidFill>
           <a:ln w="7620">
             <a:solidFill>
@@ -6116,14 +7004,14 @@
       </p:sp>
       <p:sp>
         <p:nvSpPr>
-          <p:cNvPr id="15" name="Text 13"/>
-          <p:cNvSpPr/>
-          <p:nvPr/>
-        </p:nvSpPr>
-        <p:spPr>
-          <a:xfrm>
-            <a:off x="1819656" y="1527048"/>
-            <a:ext cx="2157984" cy="457200"/>
+          <p:cNvPr id="7" name="Text 5"/>
+          <p:cNvSpPr/>
+          <p:nvPr/>
+        </p:nvSpPr>
+        <p:spPr>
+          <a:xfrm>
+            <a:off x="667512" y="941832"/>
+            <a:ext cx="1005840" cy="457200"/>
           </a:xfrm>
           <a:prstGeom prst="rect">
             <a:avLst/>
@@ -6141,33 +7029,33 @@
               <a:buNone/>
             </a:pPr>
             <a:r>
-              <a:rPr lang="en-US" sz="920" dirty="0">
-                <a:solidFill>
-                  <a:srgbClr val="182230"/>
-                </a:solidFill>
-              </a:rPr>
-              <a:t>로그인과 상단 요약</a:t>
-            </a:r>
-            <a:endParaRPr lang="en-US" sz="920" dirty="0"/>
-          </a:p>
-        </p:txBody>
-      </p:sp>
-      <p:sp>
-        <p:nvSpPr>
-          <p:cNvPr id="16" name="Shape 14"/>
-          <p:cNvSpPr/>
-          <p:nvPr/>
-        </p:nvSpPr>
-        <p:spPr>
-          <a:xfrm>
-            <a:off x="4050792" y="1453896"/>
-            <a:ext cx="2944368" cy="585216"/>
-          </a:xfrm>
-          <a:prstGeom prst="rect">
-            <a:avLst/>
-          </a:prstGeom>
-          <a:solidFill>
-            <a:srgbClr val="FFFFFF"/>
+              <a:rPr lang="en-US" sz="1000" b="1" dirty="0">
+                <a:solidFill>
+                  <a:srgbClr val="FFFFFF"/>
+                </a:solidFill>
+              </a:rPr>
+              <a:t>구간</a:t>
+            </a:r>
+            <a:endParaRPr lang="en-US" sz="1000" dirty="0"/>
+          </a:p>
+        </p:txBody>
+      </p:sp>
+      <p:sp>
+        <p:nvSpPr>
+          <p:cNvPr id="8" name="Shape 6"/>
+          <p:cNvSpPr/>
+          <p:nvPr/>
+        </p:nvSpPr>
+        <p:spPr>
+          <a:xfrm>
+            <a:off x="1746504" y="868680"/>
+            <a:ext cx="2304288" cy="585216"/>
+          </a:xfrm>
+          <a:prstGeom prst="rect">
+            <a:avLst/>
+          </a:prstGeom>
+          <a:solidFill>
+            <a:srgbClr val="122033"/>
           </a:solidFill>
           <a:ln w="7620">
             <a:solidFill>
@@ -6179,14 +7067,14 @@
       </p:sp>
       <p:sp>
         <p:nvSpPr>
-          <p:cNvPr id="17" name="Text 15"/>
-          <p:cNvSpPr/>
-          <p:nvPr/>
-        </p:nvSpPr>
-        <p:spPr>
-          <a:xfrm>
-            <a:off x="4123944" y="1527048"/>
-            <a:ext cx="2798064" cy="457200"/>
+          <p:cNvPr id="9" name="Text 7"/>
+          <p:cNvSpPr/>
+          <p:nvPr/>
+        </p:nvSpPr>
+        <p:spPr>
+          <a:xfrm>
+            <a:off x="1819656" y="941832"/>
+            <a:ext cx="2157984" cy="457200"/>
           </a:xfrm>
           <a:prstGeom prst="rect">
             <a:avLst/>
@@ -6204,33 +7092,33 @@
               <a:buNone/>
             </a:pPr>
             <a:r>
-              <a:rPr lang="en-US" sz="920" dirty="0">
-                <a:solidFill>
-                  <a:srgbClr val="182230"/>
-                </a:solidFill>
-              </a:rPr>
-              <a:t>Java 웹앱으로 실행되는 점 설명</a:t>
-            </a:r>
-            <a:endParaRPr lang="en-US" sz="920" dirty="0"/>
-          </a:p>
-        </p:txBody>
-      </p:sp>
-      <p:sp>
-        <p:nvSpPr>
-          <p:cNvPr id="18" name="Shape 16"/>
-          <p:cNvSpPr/>
-          <p:nvPr/>
-        </p:nvSpPr>
-        <p:spPr>
-          <a:xfrm>
-            <a:off x="594360" y="2039112"/>
-            <a:ext cx="1152144" cy="585216"/>
-          </a:xfrm>
-          <a:prstGeom prst="rect">
-            <a:avLst/>
-          </a:prstGeom>
-          <a:solidFill>
-            <a:srgbClr val="F6F9FD"/>
+              <a:rPr lang="en-US" sz="1000" b="1" dirty="0">
+                <a:solidFill>
+                  <a:srgbClr val="FFFFFF"/>
+                </a:solidFill>
+              </a:rPr>
+              <a:t>보여줄 화면</a:t>
+            </a:r>
+            <a:endParaRPr lang="en-US" sz="1000" dirty="0"/>
+          </a:p>
+        </p:txBody>
+      </p:sp>
+      <p:sp>
+        <p:nvSpPr>
+          <p:cNvPr id="10" name="Shape 8"/>
+          <p:cNvSpPr/>
+          <p:nvPr/>
+        </p:nvSpPr>
+        <p:spPr>
+          <a:xfrm>
+            <a:off x="4050792" y="868680"/>
+            <a:ext cx="2944368" cy="585216"/>
+          </a:xfrm>
+          <a:prstGeom prst="rect">
+            <a:avLst/>
+          </a:prstGeom>
+          <a:solidFill>
+            <a:srgbClr val="122033"/>
           </a:solidFill>
           <a:ln w="7620">
             <a:solidFill>
@@ -6242,14 +7130,14 @@
       </p:sp>
       <p:sp>
         <p:nvSpPr>
-          <p:cNvPr id="19" name="Text 17"/>
-          <p:cNvSpPr/>
-          <p:nvPr/>
-        </p:nvSpPr>
-        <p:spPr>
-          <a:xfrm>
-            <a:off x="667512" y="2112264"/>
-            <a:ext cx="1005840" cy="457200"/>
+          <p:cNvPr id="11" name="Text 9"/>
+          <p:cNvSpPr/>
+          <p:nvPr/>
+        </p:nvSpPr>
+        <p:spPr>
+          <a:xfrm>
+            <a:off x="4123944" y="941832"/>
+            <a:ext cx="2798064" cy="457200"/>
           </a:xfrm>
           <a:prstGeom prst="rect">
             <a:avLst/>
@@ -6267,33 +7155,33 @@
               <a:buNone/>
             </a:pPr>
             <a:r>
-              <a:rPr lang="en-US" sz="920" dirty="0">
-                <a:solidFill>
-                  <a:srgbClr val="182230"/>
-                </a:solidFill>
-              </a:rPr>
-              <a:t>10~25초</a:t>
-            </a:r>
-            <a:endParaRPr lang="en-US" sz="920" dirty="0"/>
-          </a:p>
-        </p:txBody>
-      </p:sp>
-      <p:sp>
-        <p:nvSpPr>
-          <p:cNvPr id="20" name="Shape 18"/>
-          <p:cNvSpPr/>
-          <p:nvPr/>
-        </p:nvSpPr>
-        <p:spPr>
-          <a:xfrm>
-            <a:off x="1746504" y="2039112"/>
-            <a:ext cx="2304288" cy="585216"/>
-          </a:xfrm>
-          <a:prstGeom prst="rect">
-            <a:avLst/>
-          </a:prstGeom>
-          <a:solidFill>
-            <a:srgbClr val="F6F9FD"/>
+              <a:rPr lang="en-US" sz="1000" b="1" dirty="0">
+                <a:solidFill>
+                  <a:srgbClr val="FFFFFF"/>
+                </a:solidFill>
+              </a:rPr>
+              <a:t>말할 내용</a:t>
+            </a:r>
+            <a:endParaRPr lang="en-US" sz="1000" dirty="0"/>
+          </a:p>
+        </p:txBody>
+      </p:sp>
+      <p:sp>
+        <p:nvSpPr>
+          <p:cNvPr id="12" name="Shape 10"/>
+          <p:cNvSpPr/>
+          <p:nvPr/>
+        </p:nvSpPr>
+        <p:spPr>
+          <a:xfrm>
+            <a:off x="594360" y="1453896"/>
+            <a:ext cx="1152144" cy="585216"/>
+          </a:xfrm>
+          <a:prstGeom prst="rect">
+            <a:avLst/>
+          </a:prstGeom>
+          <a:solidFill>
+            <a:srgbClr val="FFFFFF"/>
           </a:solidFill>
           <a:ln w="7620">
             <a:solidFill>
@@ -6305,14 +7193,14 @@
       </p:sp>
       <p:sp>
         <p:nvSpPr>
-          <p:cNvPr id="21" name="Text 19"/>
-          <p:cNvSpPr/>
-          <p:nvPr/>
-        </p:nvSpPr>
-        <p:spPr>
-          <a:xfrm>
-            <a:off x="1819656" y="2112264"/>
-            <a:ext cx="2157984" cy="457200"/>
+          <p:cNvPr id="13" name="Text 11"/>
+          <p:cNvSpPr/>
+          <p:nvPr/>
+        </p:nvSpPr>
+        <p:spPr>
+          <a:xfrm>
+            <a:off x="667512" y="1527048"/>
+            <a:ext cx="1005840" cy="457200"/>
           </a:xfrm>
           <a:prstGeom prst="rect">
             <a:avLst/>
@@ -6335,7 +7223,7 @@
                   <a:srgbClr val="182230"/>
                 </a:solidFill>
               </a:rPr>
-              <a:t>시장 시세와 검색</a:t>
+              <a:t>0~10초</a:t>
             </a:r>
             <a:endParaRPr lang="en-US" sz="920" dirty="0"/>
           </a:p>
@@ -6343,20 +7231,20 @@
       </p:sp>
       <p:sp>
         <p:nvSpPr>
-          <p:cNvPr id="22" name="Shape 20"/>
-          <p:cNvSpPr/>
-          <p:nvPr/>
-        </p:nvSpPr>
-        <p:spPr>
-          <a:xfrm>
-            <a:off x="4050792" y="2039112"/>
-            <a:ext cx="2944368" cy="585216"/>
-          </a:xfrm>
-          <a:prstGeom prst="rect">
-            <a:avLst/>
-          </a:prstGeom>
-          <a:solidFill>
-            <a:srgbClr val="F6F9FD"/>
+          <p:cNvPr id="14" name="Shape 12"/>
+          <p:cNvSpPr/>
+          <p:nvPr/>
+        </p:nvSpPr>
+        <p:spPr>
+          <a:xfrm>
+            <a:off x="1746504" y="1453896"/>
+            <a:ext cx="2304288" cy="585216"/>
+          </a:xfrm>
+          <a:prstGeom prst="rect">
+            <a:avLst/>
+          </a:prstGeom>
+          <a:solidFill>
+            <a:srgbClr val="FFFFFF"/>
           </a:solidFill>
           <a:ln w="7620">
             <a:solidFill>
@@ -6368,14 +7256,14 @@
       </p:sp>
       <p:sp>
         <p:nvSpPr>
-          <p:cNvPr id="23" name="Text 21"/>
-          <p:cNvSpPr/>
-          <p:nvPr/>
-        </p:nvSpPr>
-        <p:spPr>
-          <a:xfrm>
-            <a:off x="4123944" y="2112264"/>
-            <a:ext cx="2798064" cy="457200"/>
+          <p:cNvPr id="15" name="Text 13"/>
+          <p:cNvSpPr/>
+          <p:nvPr/>
+        </p:nvSpPr>
+        <p:spPr>
+          <a:xfrm>
+            <a:off x="1819656" y="1527048"/>
+            <a:ext cx="2157984" cy="457200"/>
           </a:xfrm>
           <a:prstGeom prst="rect">
             <a:avLst/>
@@ -6398,7 +7286,7 @@
                   <a:srgbClr val="182230"/>
                 </a:solidFill>
               </a:rPr>
-              <a:t>거래량 상위 종목과 검색/즐겨찾기</a:t>
+              <a:t>로그인과 상단 요약</a:t>
             </a:r>
             <a:endParaRPr lang="en-US" sz="920" dirty="0"/>
           </a:p>
@@ -6406,14 +7294,14 @@
       </p:sp>
       <p:sp>
         <p:nvSpPr>
-          <p:cNvPr id="24" name="Shape 22"/>
-          <p:cNvSpPr/>
-          <p:nvPr/>
-        </p:nvSpPr>
-        <p:spPr>
-          <a:xfrm>
-            <a:off x="594360" y="2624328"/>
-            <a:ext cx="1152144" cy="585216"/>
+          <p:cNvPr id="16" name="Shape 14"/>
+          <p:cNvSpPr/>
+          <p:nvPr/>
+        </p:nvSpPr>
+        <p:spPr>
+          <a:xfrm>
+            <a:off x="4050792" y="1453896"/>
+            <a:ext cx="2944368" cy="585216"/>
           </a:xfrm>
           <a:prstGeom prst="rect">
             <a:avLst/>
@@ -6431,14 +7319,14 @@
       </p:sp>
       <p:sp>
         <p:nvSpPr>
-          <p:cNvPr id="25" name="Text 23"/>
-          <p:cNvSpPr/>
-          <p:nvPr/>
-        </p:nvSpPr>
-        <p:spPr>
-          <a:xfrm>
-            <a:off x="667512" y="2697480"/>
-            <a:ext cx="1005840" cy="457200"/>
+          <p:cNvPr id="17" name="Text 15"/>
+          <p:cNvSpPr/>
+          <p:nvPr/>
+        </p:nvSpPr>
+        <p:spPr>
+          <a:xfrm>
+            <a:off x="4123944" y="1527048"/>
+            <a:ext cx="2798064" cy="457200"/>
           </a:xfrm>
           <a:prstGeom prst="rect">
             <a:avLst/>
@@ -6461,7 +7349,7 @@
                   <a:srgbClr val="182230"/>
                 </a:solidFill>
               </a:rPr>
-              <a:t>25~40초</a:t>
+              <a:t>Java 웹앱으로 실행되는 점 설명</a:t>
             </a:r>
             <a:endParaRPr lang="en-US" sz="920" dirty="0"/>
           </a:p>
@@ -6469,20 +7357,20 @@
       </p:sp>
       <p:sp>
         <p:nvSpPr>
-          <p:cNvPr id="26" name="Shape 24"/>
-          <p:cNvSpPr/>
-          <p:nvPr/>
-        </p:nvSpPr>
-        <p:spPr>
-          <a:xfrm>
-            <a:off x="1746504" y="2624328"/>
-            <a:ext cx="2304288" cy="585216"/>
-          </a:xfrm>
-          <a:prstGeom prst="rect">
-            <a:avLst/>
-          </a:prstGeom>
-          <a:solidFill>
-            <a:srgbClr val="FFFFFF"/>
+          <p:cNvPr id="18" name="Shape 16"/>
+          <p:cNvSpPr/>
+          <p:nvPr/>
+        </p:nvSpPr>
+        <p:spPr>
+          <a:xfrm>
+            <a:off x="594360" y="2039112"/>
+            <a:ext cx="1152144" cy="585216"/>
+          </a:xfrm>
+          <a:prstGeom prst="rect">
+            <a:avLst/>
+          </a:prstGeom>
+          <a:solidFill>
+            <a:srgbClr val="F6F9FD"/>
           </a:solidFill>
           <a:ln w="7620">
             <a:solidFill>
@@ -6494,14 +7382,14 @@
       </p:sp>
       <p:sp>
         <p:nvSpPr>
-          <p:cNvPr id="27" name="Text 25"/>
-          <p:cNvSpPr/>
-          <p:nvPr/>
-        </p:nvSpPr>
-        <p:spPr>
-          <a:xfrm>
-            <a:off x="1819656" y="2697480"/>
-            <a:ext cx="2157984" cy="457200"/>
+          <p:cNvPr id="19" name="Text 17"/>
+          <p:cNvSpPr/>
+          <p:nvPr/>
+        </p:nvSpPr>
+        <p:spPr>
+          <a:xfrm>
+            <a:off x="667512" y="2112264"/>
+            <a:ext cx="1005840" cy="457200"/>
           </a:xfrm>
           <a:prstGeom prst="rect">
             <a:avLst/>
@@ -6524,7 +7412,7 @@
                   <a:srgbClr val="182230"/>
                 </a:solidFill>
               </a:rPr>
-              <a:t>종목 상세/그래프</a:t>
+              <a:t>10~25초</a:t>
             </a:r>
             <a:endParaRPr lang="en-US" sz="920" dirty="0"/>
           </a:p>
@@ -6532,20 +7420,20 @@
       </p:sp>
       <p:sp>
         <p:nvSpPr>
-          <p:cNvPr id="28" name="Shape 26"/>
-          <p:cNvSpPr/>
-          <p:nvPr/>
-        </p:nvSpPr>
-        <p:spPr>
-          <a:xfrm>
-            <a:off x="4050792" y="2624328"/>
-            <a:ext cx="2944368" cy="585216"/>
-          </a:xfrm>
-          <a:prstGeom prst="rect">
-            <a:avLst/>
-          </a:prstGeom>
-          <a:solidFill>
-            <a:srgbClr val="FFFFFF"/>
+          <p:cNvPr id="20" name="Shape 18"/>
+          <p:cNvSpPr/>
+          <p:nvPr/>
+        </p:nvSpPr>
+        <p:spPr>
+          <a:xfrm>
+            <a:off x="1746504" y="2039112"/>
+            <a:ext cx="2304288" cy="585216"/>
+          </a:xfrm>
+          <a:prstGeom prst="rect">
+            <a:avLst/>
+          </a:prstGeom>
+          <a:solidFill>
+            <a:srgbClr val="F6F9FD"/>
           </a:solidFill>
           <a:ln w="7620">
             <a:solidFill>
@@ -6557,14 +7445,14 @@
       </p:sp>
       <p:sp>
         <p:nvSpPr>
-          <p:cNvPr id="29" name="Text 27"/>
-          <p:cNvSpPr/>
-          <p:nvPr/>
-        </p:nvSpPr>
-        <p:spPr>
-          <a:xfrm>
-            <a:off x="4123944" y="2697480"/>
-            <a:ext cx="2798064" cy="457200"/>
+          <p:cNvPr id="21" name="Text 19"/>
+          <p:cNvSpPr/>
+          <p:nvPr/>
+        </p:nvSpPr>
+        <p:spPr>
+          <a:xfrm>
+            <a:off x="1819656" y="2112264"/>
+            <a:ext cx="2157984" cy="457200"/>
           </a:xfrm>
           <a:prstGeom prst="rect">
             <a:avLst/>
@@ -6587,7 +7475,7 @@
                   <a:srgbClr val="182230"/>
                 </a:solidFill>
               </a:rPr>
-              <a:t>현재가, 등락률, 그래프가 한 화면에 연결됨</a:t>
+              <a:t>시장 시세와 검색</a:t>
             </a:r>
             <a:endParaRPr lang="en-US" sz="920" dirty="0"/>
           </a:p>
@@ -6595,14 +7483,14 @@
       </p:sp>
       <p:sp>
         <p:nvSpPr>
-          <p:cNvPr id="30" name="Shape 28"/>
-          <p:cNvSpPr/>
-          <p:nvPr/>
-        </p:nvSpPr>
-        <p:spPr>
-          <a:xfrm>
-            <a:off x="594360" y="3209544"/>
-            <a:ext cx="1152144" cy="585216"/>
+          <p:cNvPr id="22" name="Shape 20"/>
+          <p:cNvSpPr/>
+          <p:nvPr/>
+        </p:nvSpPr>
+        <p:spPr>
+          <a:xfrm>
+            <a:off x="4050792" y="2039112"/>
+            <a:ext cx="2944368" cy="585216"/>
           </a:xfrm>
           <a:prstGeom prst="rect">
             <a:avLst/>
@@ -6620,14 +7508,14 @@
       </p:sp>
       <p:sp>
         <p:nvSpPr>
-          <p:cNvPr id="31" name="Text 29"/>
-          <p:cNvSpPr/>
-          <p:nvPr/>
-        </p:nvSpPr>
-        <p:spPr>
-          <a:xfrm>
-            <a:off x="667512" y="3282696"/>
-            <a:ext cx="1005840" cy="457200"/>
+          <p:cNvPr id="23" name="Text 21"/>
+          <p:cNvSpPr/>
+          <p:nvPr/>
+        </p:nvSpPr>
+        <p:spPr>
+          <a:xfrm>
+            <a:off x="4123944" y="2112264"/>
+            <a:ext cx="2798064" cy="457200"/>
           </a:xfrm>
           <a:prstGeom prst="rect">
             <a:avLst/>
@@ -6650,7 +7538,7 @@
                   <a:srgbClr val="182230"/>
                 </a:solidFill>
               </a:rPr>
-              <a:t>40~55초</a:t>
+              <a:t>거래량 상위 종목과 검색/즐겨찾기</a:t>
             </a:r>
             <a:endParaRPr lang="en-US" sz="920" dirty="0"/>
           </a:p>
@@ -6658,20 +7546,20 @@
       </p:sp>
       <p:sp>
         <p:nvSpPr>
-          <p:cNvPr id="32" name="Shape 30"/>
-          <p:cNvSpPr/>
-          <p:nvPr/>
-        </p:nvSpPr>
-        <p:spPr>
-          <a:xfrm>
-            <a:off x="1746504" y="3209544"/>
-            <a:ext cx="2304288" cy="585216"/>
-          </a:xfrm>
-          <a:prstGeom prst="rect">
-            <a:avLst/>
-          </a:prstGeom>
-          <a:solidFill>
-            <a:srgbClr val="F6F9FD"/>
+          <p:cNvPr id="24" name="Shape 22"/>
+          <p:cNvSpPr/>
+          <p:nvPr/>
+        </p:nvSpPr>
+        <p:spPr>
+          <a:xfrm>
+            <a:off x="594360" y="2624328"/>
+            <a:ext cx="1152144" cy="585216"/>
+          </a:xfrm>
+          <a:prstGeom prst="rect">
+            <a:avLst/>
+          </a:prstGeom>
+          <a:solidFill>
+            <a:srgbClr val="FFFFFF"/>
           </a:solidFill>
           <a:ln w="7620">
             <a:solidFill>
@@ -6683,14 +7571,14 @@
       </p:sp>
       <p:sp>
         <p:nvSpPr>
-          <p:cNvPr id="33" name="Text 31"/>
-          <p:cNvSpPr/>
-          <p:nvPr/>
-        </p:nvSpPr>
-        <p:spPr>
-          <a:xfrm>
-            <a:off x="1819656" y="3282696"/>
-            <a:ext cx="2157984" cy="457200"/>
+          <p:cNvPr id="25" name="Text 23"/>
+          <p:cNvSpPr/>
+          <p:nvPr/>
+        </p:nvSpPr>
+        <p:spPr>
+          <a:xfrm>
+            <a:off x="667512" y="2697480"/>
+            <a:ext cx="1005840" cy="457200"/>
           </a:xfrm>
           <a:prstGeom prst="rect">
             <a:avLst/>
@@ -6713,7 +7601,7 @@
                   <a:srgbClr val="182230"/>
                 </a:solidFill>
               </a:rPr>
-              <a:t>매수 후 보유 탭</a:t>
+              <a:t>25~40초</a:t>
             </a:r>
             <a:endParaRPr lang="en-US" sz="920" dirty="0"/>
           </a:p>
@@ -6721,20 +7609,20 @@
       </p:sp>
       <p:sp>
         <p:nvSpPr>
-          <p:cNvPr id="34" name="Shape 32"/>
-          <p:cNvSpPr/>
-          <p:nvPr/>
-        </p:nvSpPr>
-        <p:spPr>
-          <a:xfrm>
-            <a:off x="4050792" y="3209544"/>
-            <a:ext cx="2944368" cy="585216"/>
-          </a:xfrm>
-          <a:prstGeom prst="rect">
-            <a:avLst/>
-          </a:prstGeom>
-          <a:solidFill>
-            <a:srgbClr val="F6F9FD"/>
+          <p:cNvPr id="26" name="Shape 24"/>
+          <p:cNvSpPr/>
+          <p:nvPr/>
+        </p:nvSpPr>
+        <p:spPr>
+          <a:xfrm>
+            <a:off x="1746504" y="2624328"/>
+            <a:ext cx="2304288" cy="585216"/>
+          </a:xfrm>
+          <a:prstGeom prst="rect">
+            <a:avLst/>
+          </a:prstGeom>
+          <a:solidFill>
+            <a:srgbClr val="FFFFFF"/>
           </a:solidFill>
           <a:ln w="7620">
             <a:solidFill>
@@ -6746,14 +7634,14 @@
       </p:sp>
       <p:sp>
         <p:nvSpPr>
-          <p:cNvPr id="35" name="Text 33"/>
-          <p:cNvSpPr/>
-          <p:nvPr/>
-        </p:nvSpPr>
-        <p:spPr>
-          <a:xfrm>
-            <a:off x="4123944" y="3282696"/>
-            <a:ext cx="2798064" cy="457200"/>
+          <p:cNvPr id="27" name="Text 25"/>
+          <p:cNvSpPr/>
+          <p:nvPr/>
+        </p:nvSpPr>
+        <p:spPr>
+          <a:xfrm>
+            <a:off x="1819656" y="2697480"/>
+            <a:ext cx="2157984" cy="457200"/>
           </a:xfrm>
           <a:prstGeom prst="rect">
             <a:avLst/>
@@ -6776,39 +7664,267 @@
                   <a:srgbClr val="182230"/>
                 </a:solidFill>
               </a:rPr>
+              <a:t>종목 상세/그래프</a:t>
+            </a:r>
+            <a:endParaRPr lang="en-US" sz="920" dirty="0"/>
+          </a:p>
+        </p:txBody>
+      </p:sp>
+      <p:sp>
+        <p:nvSpPr>
+          <p:cNvPr id="28" name="Shape 26"/>
+          <p:cNvSpPr/>
+          <p:nvPr/>
+        </p:nvSpPr>
+        <p:spPr>
+          <a:xfrm>
+            <a:off x="4050792" y="2624328"/>
+            <a:ext cx="2944368" cy="585216"/>
+          </a:xfrm>
+          <a:prstGeom prst="rect">
+            <a:avLst/>
+          </a:prstGeom>
+          <a:solidFill>
+            <a:srgbClr val="FFFFFF"/>
+          </a:solidFill>
+          <a:ln w="7620">
+            <a:solidFill>
+              <a:srgbClr val="D7DEEA"/>
+            </a:solidFill>
+            <a:prstDash val="solid"/>
+          </a:ln>
+        </p:spPr>
+      </p:sp>
+      <p:sp>
+        <p:nvSpPr>
+          <p:cNvPr id="29" name="Text 27"/>
+          <p:cNvSpPr/>
+          <p:nvPr/>
+        </p:nvSpPr>
+        <p:spPr>
+          <a:xfrm>
+            <a:off x="4123944" y="2697480"/>
+            <a:ext cx="2798064" cy="457200"/>
+          </a:xfrm>
+          <a:prstGeom prst="rect">
+            <a:avLst/>
+          </a:prstGeom>
+          <a:noFill/>
+          <a:ln/>
+        </p:spPr>
+        <p:txBody>
+          <a:bodyPr wrap="square" lIns="0" tIns="0" rIns="0" bIns="0" rtlCol="0" anchor="ctr">
+            <a:normAutofit/>
+          </a:bodyPr>
+          <a:lstStyle/>
+          <a:p>
+            <a:pPr indent="0" marL="0">
+              <a:buNone/>
+            </a:pPr>
+            <a:r>
+              <a:rPr lang="en-US" sz="920" dirty="0">
+                <a:solidFill>
+                  <a:srgbClr val="182230"/>
+                </a:solidFill>
+              </a:rPr>
+              <a:t>현재가, 등락률, 그래프가 한 화면에 연결됨</a:t>
+            </a:r>
+            <a:endParaRPr lang="en-US" sz="920" dirty="0"/>
+          </a:p>
+        </p:txBody>
+      </p:sp>
+      <p:sp>
+        <p:nvSpPr>
+          <p:cNvPr id="30" name="Shape 28"/>
+          <p:cNvSpPr/>
+          <p:nvPr/>
+        </p:nvSpPr>
+        <p:spPr>
+          <a:xfrm>
+            <a:off x="594360" y="3209544"/>
+            <a:ext cx="1152144" cy="585216"/>
+          </a:xfrm>
+          <a:prstGeom prst="rect">
+            <a:avLst/>
+          </a:prstGeom>
+          <a:solidFill>
+            <a:srgbClr val="F6F9FD"/>
+          </a:solidFill>
+          <a:ln w="7620">
+            <a:solidFill>
+              <a:srgbClr val="D7DEEA"/>
+            </a:solidFill>
+            <a:prstDash val="solid"/>
+          </a:ln>
+        </p:spPr>
+      </p:sp>
+      <p:sp>
+        <p:nvSpPr>
+          <p:cNvPr id="31" name="Text 29"/>
+          <p:cNvSpPr/>
+          <p:nvPr/>
+        </p:nvSpPr>
+        <p:spPr>
+          <a:xfrm>
+            <a:off x="667512" y="3282696"/>
+            <a:ext cx="1005840" cy="457200"/>
+          </a:xfrm>
+          <a:prstGeom prst="rect">
+            <a:avLst/>
+          </a:prstGeom>
+          <a:noFill/>
+          <a:ln/>
+        </p:spPr>
+        <p:txBody>
+          <a:bodyPr wrap="square" lIns="0" tIns="0" rIns="0" bIns="0" rtlCol="0" anchor="ctr">
+            <a:normAutofit/>
+          </a:bodyPr>
+          <a:lstStyle/>
+          <a:p>
+            <a:pPr indent="0" marL="0">
+              <a:buNone/>
+            </a:pPr>
+            <a:r>
+              <a:rPr lang="en-US" sz="920" dirty="0">
+                <a:solidFill>
+                  <a:srgbClr val="182230"/>
+                </a:solidFill>
+              </a:rPr>
+              <a:t>40~55초</a:t>
+            </a:r>
+            <a:endParaRPr lang="en-US" sz="920" dirty="0"/>
+          </a:p>
+        </p:txBody>
+      </p:sp>
+      <p:sp>
+        <p:nvSpPr>
+          <p:cNvPr id="32" name="Shape 30"/>
+          <p:cNvSpPr/>
+          <p:nvPr/>
+        </p:nvSpPr>
+        <p:spPr>
+          <a:xfrm>
+            <a:off x="1746504" y="3209544"/>
+            <a:ext cx="2304288" cy="585216"/>
+          </a:xfrm>
+          <a:prstGeom prst="rect">
+            <a:avLst/>
+          </a:prstGeom>
+          <a:solidFill>
+            <a:srgbClr val="F6F9FD"/>
+          </a:solidFill>
+          <a:ln w="7620">
+            <a:solidFill>
+              <a:srgbClr val="D7DEEA"/>
+            </a:solidFill>
+            <a:prstDash val="solid"/>
+          </a:ln>
+        </p:spPr>
+      </p:sp>
+      <p:sp>
+        <p:nvSpPr>
+          <p:cNvPr id="33" name="Text 31"/>
+          <p:cNvSpPr/>
+          <p:nvPr/>
+        </p:nvSpPr>
+        <p:spPr>
+          <a:xfrm>
+            <a:off x="1819656" y="3282696"/>
+            <a:ext cx="2157984" cy="457200"/>
+          </a:xfrm>
+          <a:prstGeom prst="rect">
+            <a:avLst/>
+          </a:prstGeom>
+          <a:noFill/>
+          <a:ln/>
+        </p:spPr>
+        <p:txBody>
+          <a:bodyPr wrap="square" lIns="0" tIns="0" rIns="0" bIns="0" rtlCol="0" anchor="ctr">
+            <a:normAutofit/>
+          </a:bodyPr>
+          <a:lstStyle/>
+          <a:p>
+            <a:pPr indent="0" marL="0">
+              <a:buNone/>
+            </a:pPr>
+            <a:r>
+              <a:rPr lang="en-US" sz="920" dirty="0">
+                <a:solidFill>
+                  <a:srgbClr val="182230"/>
+                </a:solidFill>
+              </a:rPr>
+              <a:t>매수 후 보유 탭</a:t>
+            </a:r>
+            <a:endParaRPr lang="en-US" sz="920" dirty="0"/>
+          </a:p>
+        </p:txBody>
+      </p:sp>
+      <p:sp>
+        <p:nvSpPr>
+          <p:cNvPr id="34" name="Shape 32"/>
+          <p:cNvSpPr/>
+          <p:nvPr/>
+        </p:nvSpPr>
+        <p:spPr>
+          <a:xfrm>
+            <a:off x="4050792" y="3209544"/>
+            <a:ext cx="2944368" cy="585216"/>
+          </a:xfrm>
+          <a:prstGeom prst="rect">
+            <a:avLst/>
+          </a:prstGeom>
+          <a:solidFill>
+            <a:srgbClr val="F6F9FD"/>
+          </a:solidFill>
+          <a:ln w="7620">
+            <a:solidFill>
+              <a:srgbClr val="D7DEEA"/>
+            </a:solidFill>
+            <a:prstDash val="solid"/>
+          </a:ln>
+        </p:spPr>
+      </p:sp>
+      <p:sp>
+        <p:nvSpPr>
+          <p:cNvPr id="35" name="Text 33"/>
+          <p:cNvSpPr/>
+          <p:nvPr/>
+        </p:nvSpPr>
+        <p:spPr>
+          <a:xfrm>
+            <a:off x="4123944" y="3282696"/>
+            <a:ext cx="2798064" cy="457200"/>
+          </a:xfrm>
+          <a:prstGeom prst="rect">
+            <a:avLst/>
+          </a:prstGeom>
+          <a:noFill/>
+          <a:ln/>
+        </p:spPr>
+        <p:txBody>
+          <a:bodyPr wrap="square" lIns="0" tIns="0" rIns="0" bIns="0" rtlCol="0" anchor="ctr">
+            <a:normAutofit/>
+          </a:bodyPr>
+          <a:lstStyle/>
+          <a:p>
+            <a:pPr indent="0" marL="0">
+              <a:buNone/>
+            </a:pPr>
+            <a:r>
+              <a:rPr lang="en-US" sz="920" dirty="0">
+                <a:solidFill>
+                  <a:srgbClr val="182230"/>
+                </a:solidFill>
+              </a:rPr>
               <a:t>종목을 클릭해 매수하고 손익을 확인</a:t>
             </a:r>
             <a:endParaRPr lang="en-US" sz="920" dirty="0"/>
           </a:p>
         </p:txBody>
       </p:sp>
-      <p:pic>
-        <p:nvPicPr>
-          <p:cNvPr id="36" name="Image 0" descr="C:\Users\user\Documents\Codex\2026-05-19\100\deliverables\mock-stock-website-demo-preview.png">    </p:cNvPr>
-          <p:cNvPicPr>
-            <a:picLocks noChangeAspect="1"/>
-          </p:cNvPicPr>
-          <p:nvPr/>
-        </p:nvPicPr>
-        <p:blipFill>
-          <a:blip r:embed="rId1"/>
-          <a:stretch>
-            <a:fillRect/>
-          </a:stretch>
-        </p:blipFill>
-        <p:spPr>
-          <a:xfrm>
-            <a:off x="7315200" y="914400"/>
-            <a:ext cx="4297680" cy="2423160"/>
-          </a:xfrm>
-          <a:prstGeom prst="rect">
-            <a:avLst/>
-          </a:prstGeom>
-        </p:spPr>
-      </p:pic>
-      <p:sp>
-        <p:nvSpPr>
-          <p:cNvPr id="37" name="Text 34"/>
+      <p:sp>
+        <p:nvSpPr>
+          <p:cNvPr id="36" name="Text 34"/>
           <p:cNvSpPr/>
           <p:nvPr/>
         </p:nvSpPr>
@@ -6844,7 +7960,7 @@
       </p:sp>
       <p:sp>
         <p:nvSpPr>
-          <p:cNvPr id="38" name="Text 35"/>
+          <p:cNvPr id="37" name="Text 35"/>
           <p:cNvSpPr/>
           <p:nvPr/>
         </p:nvSpPr>
@@ -6880,7 +7996,7 @@
       </p:sp>
       <p:sp>
         <p:nvSpPr>
-          <p:cNvPr id="39" name="Text 36"/>
+          <p:cNvPr id="38" name="Text 36"/>
           <p:cNvSpPr/>
           <p:nvPr/>
         </p:nvSpPr>

</xml_diff>

<commit_message>
Improve security sessions and update project docs
</commit_message>
<xml_diff>
--- a/deliverables/Java_모의주식투자_발표자료.pptx
+++ b/deliverables/Java_모의주식투자_발표자료.pptx
@@ -20,9 +20,10 @@
     <p:sldId id="268" r:id="rId14"/>
     <p:sldId id="269" r:id="rId15"/>
     <p:sldId id="270" r:id="rId16"/>
+    <p:sldId id="271" r:id="rId17"/>
   </p:sldIdLst>
   <p:notesMasterIdLst>
-    <p:notesMasterId r:id="rId17"/>
+    <p:notesMasterId r:id="rId18"/>
   </p:notesMasterIdLst>
   <p:sldSz cx="12191695" cy="6858000"/>
   <p:notesSz cx="6858000" cy="12191695"/>
@@ -1086,6 +1087,94 @@
 </p:notes>
 </file>
 
+<file path=ppt/notesSlides/notesSlide16.xml><?xml version="1.0" encoding="utf-8"?>
+<p:notes xmlns:a="http://schemas.openxmlformats.org/drawingml/2006/main" xmlns:r="http://schemas.openxmlformats.org/officeDocument/2006/relationships" xmlns:p="http://schemas.openxmlformats.org/presentationml/2006/main">
+  <p:cSld>
+    <p:spTree>
+      <p:nvGrpSpPr>
+        <p:cNvPr id="1" name=""/>
+        <p:cNvGrpSpPr/>
+        <p:nvPr/>
+      </p:nvGrpSpPr>
+      <p:grpSpPr>
+        <a:xfrm>
+          <a:off x="0" y="0"/>
+          <a:ext cx="0" cy="0"/>
+          <a:chOff x="0" y="0"/>
+          <a:chExt cx="0" cy="0"/>
+        </a:xfrm>
+      </p:grpSpPr>
+      <p:sp>
+        <p:nvSpPr>
+          <p:cNvPr id="2" name="Slide Image Placeholder 1"/>
+          <p:cNvSpPr>
+            <a:spLocks noGrp="1" noRot="1" noChangeAspect="1"/>
+          </p:cNvSpPr>
+          <p:nvPr>
+            <p:ph type="sldImg"/>
+          </p:nvPr>
+        </p:nvSpPr>
+        <p:spPr/>
+      </p:sp>
+      <p:sp>
+        <p:nvSpPr>
+          <p:cNvPr id="3" name="Notes Placeholder 2"/>
+          <p:cNvSpPr>
+            <a:spLocks noGrp="1"/>
+          </p:cNvSpPr>
+          <p:nvPr>
+            <p:ph type="body" idx="1"/>
+          </p:nvPr>
+        </p:nvSpPr>
+        <p:spPr/>
+        <p:txBody>
+          <a:bodyPr/>
+          <a:lstStyle/>
+          <a:p>
+            <a:r>
+              <a:rPr lang="en-US" dirty="0"/>
+              <a:t/>
+            </a:r>
+            <a:endParaRPr lang="en-US" dirty="0"/>
+          </a:p>
+        </p:txBody>
+      </p:sp>
+      <p:sp>
+        <p:nvSpPr>
+          <p:cNvPr id="4" name="Slide Number Placeholder 3"/>
+          <p:cNvSpPr>
+            <a:spLocks noGrp="1"/>
+          </p:cNvSpPr>
+          <p:nvPr>
+            <p:ph type="sldNum" sz="quarter" idx="10"/>
+          </p:nvPr>
+        </p:nvSpPr>
+        <p:spPr/>
+        <p:txBody>
+          <a:bodyPr/>
+          <a:lstStyle/>
+          <a:p>
+            <a:fld id="{F7021451-1387-4CA6-816F-3879F97B5CBC}" type="slidenum">
+              <a:rPr lang="en-US"/>
+              <a:t>16</a:t>
+            </a:fld>
+            <a:endParaRPr lang="en-US"/>
+          </a:p>
+        </p:txBody>
+      </p:sp>
+    </p:spTree>
+    <p:extLst>
+      <p:ext uri="{BB962C8B-B14F-4D97-AF65-F5344CB8AC3E}">
+        <p14:creationId xmlns:p14="http://schemas.microsoft.com/office/powerpoint/2010/main" val="1024086991"/>
+      </p:ext>
+    </p:extLst>
+  </p:cSld>
+  <p:clrMapOvr>
+    <a:masterClrMapping/>
+  </p:clrMapOvr>
+</p:notes>
+</file>
+
 <file path=ppt/notesSlides/notesSlide2.xml><?xml version="1.0" encoding="utf-8"?>
 <p:notes xmlns:a="http://schemas.openxmlformats.org/drawingml/2006/main" xmlns:r="http://schemas.openxmlformats.org/officeDocument/2006/relationships" xmlns:p="http://schemas.openxmlformats.org/presentationml/2006/main">
   <p:cSld>
@@ -4883,11 +4972,11 @@
         <p:spPr>
           <a:xfrm>
             <a:off x="685800" y="914400"/>
-            <a:ext cx="4983480" cy="1005840"/>
+            <a:ext cx="3337560" cy="1325880"/>
           </a:xfrm>
           <a:prstGeom prst="roundRect">
             <a:avLst>
-              <a:gd name="adj" fmla="val 5455"/>
+              <a:gd name="adj" fmla="val 4138"/>
             </a:avLst>
           </a:prstGeom>
           <a:solidFill>
@@ -4910,7 +4999,7 @@
         <p:spPr>
           <a:xfrm>
             <a:off x="850392" y="1060704"/>
-            <a:ext cx="4654296" cy="237744"/>
+            <a:ext cx="3008376" cy="237744"/>
           </a:xfrm>
           <a:prstGeom prst="rect">
             <a:avLst/>
@@ -4931,7 +5020,7 @@
                   <a:srgbClr val="1F5FBF"/>
                 </a:solidFill>
               </a:rPr>
-              <a:t>저장 문제</a:t>
+              <a:t>실제 시세 연동</a:t>
             </a:r>
             <a:endParaRPr lang="en-US" sz="1200" dirty="0"/>
           </a:p>
@@ -4946,7 +5035,7 @@
         <p:spPr>
           <a:xfrm>
             <a:off x="850392" y="1389888"/>
-            <a:ext cx="4654296" cy="411480"/>
+            <a:ext cx="3008376" cy="731520"/>
           </a:xfrm>
           <a:prstGeom prst="rect">
             <a:avLst/>
@@ -4969,7 +5058,7 @@
                   <a:srgbClr val="182230"/>
                 </a:solidFill>
               </a:rPr>
-              <a:t>서버 재시작 시 데이터가 사라지는 문제를 MySQL 저장 구조로 변경</a:t>
+              <a:t>내부 모의 가격과 KIS 응답값이 섞이면서 가격이 이상해 보이는 문제를 확인하고 갱신 흐름을 정리</a:t>
             </a:r>
             <a:endParaRPr lang="en-US" sz="1070" dirty="0"/>
           </a:p>
@@ -4983,12 +5072,12 @@
         </p:nvSpPr>
         <p:spPr>
           <a:xfrm>
-            <a:off x="6172200" y="914400"/>
-            <a:ext cx="4983480" cy="1005840"/>
+            <a:off x="4434840" y="914400"/>
+            <a:ext cx="3337560" cy="1325880"/>
           </a:xfrm>
           <a:prstGeom prst="roundRect">
             <a:avLst>
-              <a:gd name="adj" fmla="val 5455"/>
+              <a:gd name="adj" fmla="val 4138"/>
             </a:avLst>
           </a:prstGeom>
           <a:solidFill>
@@ -5010,8 +5099,8 @@
         </p:nvSpPr>
         <p:spPr>
           <a:xfrm>
-            <a:off x="6336792" y="1060704"/>
-            <a:ext cx="4654296" cy="237744"/>
+            <a:off x="4599432" y="1060704"/>
+            <a:ext cx="3008376" cy="237744"/>
           </a:xfrm>
           <a:prstGeom prst="rect">
             <a:avLst/>
@@ -5032,7 +5121,7 @@
                   <a:srgbClr val="1F5FBF"/>
                 </a:solidFill>
               </a:rPr>
-              <a:t>인코딩</a:t>
+              <a:t>전체 종목 처리 범위</a:t>
             </a:r>
             <a:endParaRPr lang="en-US" sz="1200" dirty="0"/>
           </a:p>
@@ -5046,8 +5135,8 @@
         </p:nvSpPr>
         <p:spPr>
           <a:xfrm>
-            <a:off x="6336792" y="1389888"/>
-            <a:ext cx="4654296" cy="411480"/>
+            <a:off x="4599432" y="1389888"/>
+            <a:ext cx="3008376" cy="731520"/>
           </a:xfrm>
           <a:prstGeom prst="rect">
             <a:avLst/>
@@ -5070,7 +5159,7 @@
                   <a:srgbClr val="182230"/>
                 </a:solidFill>
               </a:rPr>
-              <a:t>한글 UI가 깨지지 않도록 UTF-8 기준으로 정리</a:t>
+              <a:t>약 2700개 전체 종목을 계속 갱신하는 대신 거래량 상위 종목 중심으로 현실적인 범위를 선택</a:t>
             </a:r>
             <a:endParaRPr lang="en-US" sz="1070" dirty="0"/>
           </a:p>
@@ -5084,12 +5173,12 @@
         </p:nvSpPr>
         <p:spPr>
           <a:xfrm>
-            <a:off x="685800" y="2331720"/>
-            <a:ext cx="4983480" cy="1005840"/>
+            <a:off x="8183880" y="914400"/>
+            <a:ext cx="3337560" cy="1325880"/>
           </a:xfrm>
           <a:prstGeom prst="roundRect">
             <a:avLst>
-              <a:gd name="adj" fmla="val 5455"/>
+              <a:gd name="adj" fmla="val 4138"/>
             </a:avLst>
           </a:prstGeom>
           <a:solidFill>
@@ -5111,8 +5200,8 @@
         </p:nvSpPr>
         <p:spPr>
           <a:xfrm>
-            <a:off x="850392" y="2478024"/>
-            <a:ext cx="4654296" cy="237744"/>
+            <a:off x="8348472" y="1060704"/>
+            <a:ext cx="3008376" cy="237744"/>
           </a:xfrm>
           <a:prstGeom prst="rect">
             <a:avLst/>
@@ -5133,7 +5222,7 @@
                   <a:srgbClr val="1F5FBF"/>
                 </a:solidFill>
               </a:rPr>
-              <a:t>API 키</a:t>
+              <a:t>UI 흐름 개선</a:t>
             </a:r>
             <a:endParaRPr lang="en-US" sz="1200" dirty="0"/>
           </a:p>
@@ -5147,8 +5236,8 @@
         </p:nvSpPr>
         <p:spPr>
           <a:xfrm>
-            <a:off x="850392" y="2807208"/>
-            <a:ext cx="4654296" cy="411480"/>
+            <a:off x="8348472" y="1389888"/>
+            <a:ext cx="3008376" cy="731520"/>
           </a:xfrm>
           <a:prstGeom prst="rect">
             <a:avLst/>
@@ -5171,7 +5260,7 @@
                   <a:srgbClr val="182230"/>
                 </a:solidFill>
               </a:rPr>
-              <a:t>KIS 키를 환경변수로 관리</a:t>
+              <a:t>드롭다운 주문 방식 대신 종목 클릭 → 상세 확인 → 매수, 보유 종목 → 매도 흐름으로 변경</a:t>
             </a:r>
             <a:endParaRPr lang="en-US" sz="1070" dirty="0"/>
           </a:p>
@@ -5185,12 +5274,12 @@
         </p:nvSpPr>
         <p:spPr>
           <a:xfrm>
-            <a:off x="6172200" y="2331720"/>
-            <a:ext cx="4983480" cy="1005840"/>
+            <a:off x="2560320" y="3154680"/>
+            <a:ext cx="3337560" cy="1325880"/>
           </a:xfrm>
           <a:prstGeom prst="roundRect">
             <a:avLst>
-              <a:gd name="adj" fmla="val 5455"/>
+              <a:gd name="adj" fmla="val 4138"/>
             </a:avLst>
           </a:prstGeom>
           <a:solidFill>
@@ -5212,8 +5301,8 @@
         </p:nvSpPr>
         <p:spPr>
           <a:xfrm>
-            <a:off x="6336792" y="2478024"/>
-            <a:ext cx="4654296" cy="237744"/>
+            <a:off x="2724912" y="3300984"/>
+            <a:ext cx="3008376" cy="237744"/>
           </a:xfrm>
           <a:prstGeom prst="rect">
             <a:avLst/>
@@ -5234,7 +5323,7 @@
                   <a:srgbClr val="1F5FBF"/>
                 </a:solidFill>
               </a:rPr>
-              <a:t>가격 표시</a:t>
+              <a:t>뉴스 기능 제거</a:t>
             </a:r>
             <a:endParaRPr lang="en-US" sz="1200" dirty="0"/>
           </a:p>
@@ -5248,8 +5337,8 @@
         </p:nvSpPr>
         <p:spPr>
           <a:xfrm>
-            <a:off x="6336792" y="2807208"/>
-            <a:ext cx="4654296" cy="411480"/>
+            <a:off x="2724912" y="3630168"/>
+            <a:ext cx="3008376" cy="731520"/>
           </a:xfrm>
           <a:prstGeom prst="rect">
             <a:avLst/>
@@ -5272,7 +5361,7 @@
                   <a:srgbClr val="182230"/>
                 </a:solidFill>
               </a:rPr>
-              <a:t>초기값과 API값이 섞이는 문제를 확인하고 갱신 흐름을 보정</a:t>
+              <a:t>기사 품질 편차와 API 키 관리 부담 때문에 모의투자 목적에 맞지 않는 기능은 최종 제외</a:t>
             </a:r>
             <a:endParaRPr lang="en-US" sz="1070" dirty="0"/>
           </a:p>
@@ -5286,12 +5375,12 @@
         </p:nvSpPr>
         <p:spPr>
           <a:xfrm>
-            <a:off x="685800" y="3749040"/>
-            <a:ext cx="4983480" cy="1005840"/>
+            <a:off x="6309360" y="3154680"/>
+            <a:ext cx="3337560" cy="1325880"/>
           </a:xfrm>
           <a:prstGeom prst="roundRect">
             <a:avLst>
-              <a:gd name="adj" fmla="val 5455"/>
+              <a:gd name="adj" fmla="val 4138"/>
             </a:avLst>
           </a:prstGeom>
           <a:solidFill>
@@ -5313,8 +5402,8 @@
         </p:nvSpPr>
         <p:spPr>
           <a:xfrm>
-            <a:off x="850392" y="3895344"/>
-            <a:ext cx="4654296" cy="237744"/>
+            <a:off x="6473952" y="3300984"/>
+            <a:ext cx="3008376" cy="237744"/>
           </a:xfrm>
           <a:prstGeom prst="rect">
             <a:avLst/>
@@ -5335,7 +5424,7 @@
                   <a:srgbClr val="1F5FBF"/>
                 </a:solidFill>
               </a:rPr>
-              <a:t>API 지연</a:t>
+              <a:t>DB 저장 전환</a:t>
             </a:r>
             <a:endParaRPr lang="en-US" sz="1200" dirty="0"/>
           </a:p>
@@ -5349,8 +5438,8 @@
         </p:nvSpPr>
         <p:spPr>
           <a:xfrm>
-            <a:off x="850392" y="4224528"/>
-            <a:ext cx="4654296" cy="411480"/>
+            <a:off x="6473952" y="3630168"/>
+            <a:ext cx="3008376" cy="731520"/>
           </a:xfrm>
           <a:prstGeom prst="rect">
             <a:avLst/>
@@ -5373,108 +5462,7 @@
                   <a:srgbClr val="182230"/>
                 </a:solidFill>
               </a:rPr>
-              <a:t>2700개 전체 조회 대신 거래량 상위 종목 중심으로 범위 축소</a:t>
-            </a:r>
-            <a:endParaRPr lang="en-US" sz="1070" dirty="0"/>
-          </a:p>
-        </p:txBody>
-      </p:sp>
-      <p:sp>
-        <p:nvSpPr>
-          <p:cNvPr id="21" name="Shape 19"/>
-          <p:cNvSpPr/>
-          <p:nvPr/>
-        </p:nvSpPr>
-        <p:spPr>
-          <a:xfrm>
-            <a:off x="6172200" y="3749040"/>
-            <a:ext cx="4983480" cy="1005840"/>
-          </a:xfrm>
-          <a:prstGeom prst="roundRect">
-            <a:avLst>
-              <a:gd name="adj" fmla="val 5455"/>
-            </a:avLst>
-          </a:prstGeom>
-          <a:solidFill>
-            <a:srgbClr val="FFFFFF"/>
-          </a:solidFill>
-          <a:ln w="12700">
-            <a:solidFill>
-              <a:srgbClr val="D7DEEA"/>
-            </a:solidFill>
-            <a:prstDash val="solid"/>
-          </a:ln>
-        </p:spPr>
-      </p:sp>
-      <p:sp>
-        <p:nvSpPr>
-          <p:cNvPr id="22" name="Text 20"/>
-          <p:cNvSpPr/>
-          <p:nvPr/>
-        </p:nvSpPr>
-        <p:spPr>
-          <a:xfrm>
-            <a:off x="6336792" y="3895344"/>
-            <a:ext cx="4654296" cy="237744"/>
-          </a:xfrm>
-          <a:prstGeom prst="rect">
-            <a:avLst/>
-          </a:prstGeom>
-          <a:noFill/>
-          <a:ln/>
-        </p:spPr>
-        <p:txBody>
-          <a:bodyPr wrap="square" lIns="0" tIns="0" rIns="0" bIns="0" rtlCol="0" anchor="ctr"/>
-          <a:lstStyle/>
-          <a:p>
-            <a:pPr indent="0" marL="0">
-              <a:buNone/>
-            </a:pPr>
-            <a:r>
-              <a:rPr lang="en-US" sz="1200" b="1" dirty="0">
-                <a:solidFill>
-                  <a:srgbClr val="1F5FBF"/>
-                </a:solidFill>
-              </a:rPr>
-              <a:t>UI 단순화</a:t>
-            </a:r>
-            <a:endParaRPr lang="en-US" sz="1200" dirty="0"/>
-          </a:p>
-        </p:txBody>
-      </p:sp>
-      <p:sp>
-        <p:nvSpPr>
-          <p:cNvPr id="23" name="Text 21"/>
-          <p:cNvSpPr/>
-          <p:nvPr/>
-        </p:nvSpPr>
-        <p:spPr>
-          <a:xfrm>
-            <a:off x="6336792" y="4224528"/>
-            <a:ext cx="4654296" cy="411480"/>
-          </a:xfrm>
-          <a:prstGeom prst="rect">
-            <a:avLst/>
-          </a:prstGeom>
-          <a:noFill/>
-          <a:ln/>
-        </p:spPr>
-        <p:txBody>
-          <a:bodyPr wrap="square" lIns="381" tIns="381" rIns="381" bIns="381" rtlCol="0" anchor="ctr">
-            <a:normAutofit/>
-          </a:bodyPr>
-          <a:lstStyle/>
-          <a:p>
-            <a:pPr indent="0" marL="0">
-              <a:buNone/>
-            </a:pPr>
-            <a:r>
-              <a:rPr lang="en-US" sz="1070" dirty="0">
-                <a:solidFill>
-                  <a:srgbClr val="182230"/>
-                </a:solidFill>
-              </a:rPr>
-              <a:t>운세/수동 날짜 진행 제거, 검색·즐겨찾기·상세 매매 흐름 강화</a:t>
+              <a:t>서버를 껐다 켜면 기록이 사라지는 문제를 MySQL 저장 구조로 바꿔 거래 기록을 유지</a:t>
             </a:r>
             <a:endParaRPr lang="en-US" sz="1070" dirty="0"/>
           </a:p>
@@ -5758,6 +5746,20 @@
                 <a:ea typeface="Malgun Gothic" pitchFamily="34" charset="-122"/>
                 <a:cs typeface="Malgun Gothic" pitchFamily="34" charset="-120"/>
               </a:rPr>
+              <a:t>SecureRandom, MessageDigest: 비밀번호 Salt 생성과 해시 검증</a:t>
+            </a:r>
+            <a:endParaRPr lang="en-US" sz="1400" dirty="0"/>
+          </a:p>
+          <a:p>
+            <a:r>
+              <a:rPr lang="en-US" sz="1400" dirty="0">
+                <a:solidFill>
+                  <a:srgbClr val="182230"/>
+                </a:solidFill>
+                <a:latin typeface="Malgun Gothic" pitchFamily="34" charset="0"/>
+                <a:ea typeface="Malgun Gothic" pitchFamily="34" charset="-122"/>
+                <a:cs typeface="Malgun Gothic" pitchFamily="34" charset="-120"/>
+              </a:rPr>
               <a:t>LocalDateTime, DateTimeFormatter: 거래 시간과 시세 갱신 시각 표시</a:t>
             </a:r>
             <a:endParaRPr lang="en-US" sz="1400" dirty="0"/>
@@ -6027,7 +6029,7 @@
                 <a:ea typeface="Consolas" pitchFamily="34" charset="-122"/>
                 <a:cs typeface="Consolas" pitchFamily="34" charset="-120"/>
               </a:rPr>
-              <a:t>if ("GET".equals(method) &amp;&amp; "/api/state".equals(path)) {</a:t>
+              <a:t>String sessionId = sessionCookie(exchange);</a:t>
             </a:r>
             <a:endParaRPr lang="en-US" sz="690" dirty="0"/>
           </a:p>
@@ -6044,7 +6046,7 @@
                 <a:ea typeface="Consolas" pitchFamily="34" charset="-122"/>
                 <a:cs typeface="Consolas" pitchFamily="34" charset="-120"/>
               </a:rPr>
-              <a:t>    send(exchange, 200, "application/json", project.stateJson());</a:t>
+              <a:t>if ("GET".equals(method) &amp;&amp; "/api/state".equals(path)) {</a:t>
             </a:r>
             <a:endParaRPr lang="en-US" sz="690" dirty="0"/>
           </a:p>
@@ -6061,7 +6063,7 @@
                 <a:ea typeface="Consolas" pitchFamily="34" charset="-122"/>
                 <a:cs typeface="Consolas" pitchFamily="34" charset="-120"/>
               </a:rPr>
-              <a:t>}</a:t>
+              <a:t>    send(exchange, 200, "application/json", project.stateJson(sessionId));</a:t>
             </a:r>
             <a:endParaRPr lang="en-US" sz="690" dirty="0"/>
           </a:p>
@@ -6078,7 +6080,7 @@
                 <a:ea typeface="Consolas" pitchFamily="34" charset="-122"/>
                 <a:cs typeface="Consolas" pitchFamily="34" charset="-120"/>
               </a:rPr>
-              <a:t>String json = switch (path) {</a:t>
+              <a:t>}</a:t>
             </a:r>
             <a:endParaRPr lang="en-US" sz="690" dirty="0"/>
           </a:p>
@@ -6095,7 +6097,7 @@
                 <a:ea typeface="Consolas" pitchFamily="34" charset="-122"/>
                 <a:cs typeface="Consolas" pitchFamily="34" charset="-120"/>
               </a:rPr>
-              <a:t>    case "/api/stock/buy" -&gt; project.buyStock(body);</a:t>
+              <a:t>String json = switch (path) {</a:t>
             </a:r>
             <a:endParaRPr lang="en-US" sz="690" dirty="0"/>
           </a:p>
@@ -6112,7 +6114,24 @@
                 <a:ea typeface="Consolas" pitchFamily="34" charset="-122"/>
                 <a:cs typeface="Consolas" pitchFamily="34" charset="-120"/>
               </a:rPr>
-              <a:t>    case "/api/stock/sell" -&gt; project.sellStock(body);</a:t>
+              <a:t>    case "/api/stock/buy" -&gt; project.buyStock(body, sessionId);</a:t>
+            </a:r>
+            <a:endParaRPr lang="en-US" sz="690" dirty="0"/>
+          </a:p>
+          <a:p>
+            <a:pPr indent="0" marL="0">
+              <a:buNone/>
+            </a:pPr>
+            <a:r>
+              <a:rPr lang="en-US" sz="690" dirty="0">
+                <a:solidFill>
+                  <a:srgbClr val="E5E7EB"/>
+                </a:solidFill>
+                <a:latin typeface="Consolas" pitchFamily="34" charset="0"/>
+                <a:ea typeface="Consolas" pitchFamily="34" charset="-122"/>
+                <a:cs typeface="Consolas" pitchFamily="34" charset="-120"/>
+              </a:rPr>
+              <a:t>    case "/api/stock/sell" -&gt; project.sellStock(body, sessionId);</a:t>
             </a:r>
             <a:endParaRPr lang="en-US" sz="690" dirty="0"/>
           </a:p>
@@ -6462,7 +6481,7 @@
                 <a:ea typeface="Consolas" pitchFamily="34" charset="-122"/>
                 <a:cs typeface="Consolas" pitchFamily="34" charset="-120"/>
               </a:rPr>
-              <a:t>Stock stock = findStock(stockName);</a:t>
+              <a:t>Member member = member(sessionId);</a:t>
             </a:r>
             <a:endParaRPr lang="en-US" sz="690" dirty="0"/>
           </a:p>
@@ -6479,7 +6498,7 @@
                 <a:ea typeface="Consolas" pitchFamily="34" charset="-122"/>
                 <a:cs typeface="Consolas" pitchFamily="34" charset="-120"/>
               </a:rPr>
-              <a:t>long total = (long) stock.price * quantity;</a:t>
+              <a:t>Stock stock = member.stocks.get(stockName);</a:t>
             </a:r>
             <a:endParaRPr lang="en-US" sz="690" dirty="0"/>
           </a:p>
@@ -6496,7 +6515,7 @@
                 <a:ea typeface="Consolas" pitchFamily="34" charset="-122"/>
                 <a:cs typeface="Consolas" pitchFamily="34" charset="-120"/>
               </a:rPr>
-              <a:t>if (currentMember.balance &lt; total) return Json.obj("ok", false);</a:t>
+              <a:t>long total = (long) stock.price * quantity;</a:t>
             </a:r>
             <a:endParaRPr lang="en-US" sz="690" dirty="0"/>
           </a:p>
@@ -6513,7 +6532,7 @@
                 <a:ea typeface="Consolas" pitchFamily="34" charset="-122"/>
                 <a:cs typeface="Consolas" pitchFamily="34" charset="-120"/>
               </a:rPr>
-              <a:t>currentMember.balance -= total;</a:t>
+              <a:t>if (member.balance &lt; total) return Json.obj("ok", false);</a:t>
             </a:r>
             <a:endParaRPr lang="en-US" sz="690" dirty="0"/>
           </a:p>
@@ -6530,7 +6549,7 @@
                 <a:ea typeface="Consolas" pitchFamily="34" charset="-122"/>
                 <a:cs typeface="Consolas" pitchFamily="34" charset="-120"/>
               </a:rPr>
-              <a:t>currentMember.shares.put(stockName, share.buy(quantity, total));</a:t>
+              <a:t>member.balance -= total;</a:t>
             </a:r>
             <a:endParaRPr lang="en-US" sz="690" dirty="0"/>
           </a:p>
@@ -6547,7 +6566,24 @@
                 <a:ea typeface="Consolas" pitchFamily="34" charset="-122"/>
                 <a:cs typeface="Consolas" pitchFamily="34" charset="-120"/>
               </a:rPr>
-              <a:t>logs.add(new TradeLog(currentMember.uid, stockName, quantity, total, "구매"));</a:t>
+              <a:t>member.shares.put(stockName, share.buy(quantity, total));</a:t>
+            </a:r>
+            <a:endParaRPr lang="en-US" sz="690" dirty="0"/>
+          </a:p>
+          <a:p>
+            <a:pPr indent="0" marL="0">
+              <a:buNone/>
+            </a:pPr>
+            <a:r>
+              <a:rPr lang="en-US" sz="690" dirty="0">
+                <a:solidFill>
+                  <a:srgbClr val="E5E7EB"/>
+                </a:solidFill>
+                <a:latin typeface="Consolas" pitchFamily="34" charset="0"/>
+                <a:ea typeface="Consolas" pitchFamily="34" charset="-122"/>
+                <a:cs typeface="Consolas" pitchFamily="34" charset="-120"/>
+              </a:rPr>
+              <a:t>logs.add(new TradeLog(member.uid, stockName, quantity, total, "구매"));</a:t>
             </a:r>
             <a:endParaRPr lang="en-US" sz="690" dirty="0"/>
           </a:p>
@@ -6912,6 +6948,774 @@
                 <a:ea typeface="Malgun Gothic" pitchFamily="34" charset="-122"/>
                 <a:cs typeface="Malgun Gothic" pitchFamily="34" charset="-120"/>
               </a:rPr>
+              <a:t>보완 상태와 남은 과제</a:t>
+            </a:r>
+            <a:endParaRPr lang="en-US" sz="1600" dirty="0"/>
+          </a:p>
+        </p:txBody>
+      </p:sp>
+      <p:sp>
+        <p:nvSpPr>
+          <p:cNvPr id="4" name="Shape 2"/>
+          <p:cNvSpPr/>
+          <p:nvPr/>
+        </p:nvSpPr>
+        <p:spPr>
+          <a:xfrm>
+            <a:off x="320040" y="594360"/>
+            <a:ext cx="11521440" cy="0"/>
+          </a:xfrm>
+          <a:prstGeom prst="line">
+            <a:avLst/>
+          </a:prstGeom>
+          <a:noFill/>
+          <a:ln w="12700">
+            <a:solidFill>
+              <a:srgbClr val="D7DEEA"/>
+            </a:solidFill>
+            <a:prstDash val="solid"/>
+          </a:ln>
+        </p:spPr>
+      </p:sp>
+      <p:sp>
+        <p:nvSpPr>
+          <p:cNvPr id="5" name="Text 3"/>
+          <p:cNvSpPr/>
+          <p:nvPr/>
+        </p:nvSpPr>
+        <p:spPr>
+          <a:xfrm>
+            <a:off x="411480" y="6547104"/>
+            <a:ext cx="7680960" cy="146304"/>
+          </a:xfrm>
+          <a:prstGeom prst="rect">
+            <a:avLst/>
+          </a:prstGeom>
+          <a:noFill/>
+          <a:ln/>
+        </p:spPr>
+        <p:txBody>
+          <a:bodyPr wrap="square" lIns="0" tIns="0" rIns="0" bIns="0" rtlCol="0" anchor="ctr"/>
+          <a:lstStyle/>
+          <a:p>
+            <a:pPr indent="0" marL="0">
+              <a:buNone/>
+            </a:pPr>
+            <a:r>
+              <a:rPr lang="en-US" sz="750" dirty="0">
+                <a:solidFill>
+                  <a:srgbClr val="7A8797"/>
+                </a:solidFill>
+              </a:rPr>
+              <a:t>Java 프로젝트 모의주식 | KIS Open API · MySQL · 소켓 기반 모의투자 웹앱</a:t>
+            </a:r>
+            <a:endParaRPr lang="en-US" sz="750" dirty="0"/>
+          </a:p>
+        </p:txBody>
+      </p:sp>
+      <p:sp>
+        <p:nvSpPr>
+          <p:cNvPr id="6" name="Shape 4"/>
+          <p:cNvSpPr/>
+          <p:nvPr/>
+        </p:nvSpPr>
+        <p:spPr>
+          <a:xfrm>
+            <a:off x="640080" y="914400"/>
+            <a:ext cx="5257800" cy="1097280"/>
+          </a:xfrm>
+          <a:prstGeom prst="roundRect">
+            <a:avLst>
+              <a:gd name="adj" fmla="val 5000"/>
+            </a:avLst>
+          </a:prstGeom>
+          <a:solidFill>
+            <a:srgbClr val="EAF2FF"/>
+          </a:solidFill>
+          <a:ln w="12700">
+            <a:solidFill>
+              <a:srgbClr val="D7DEEA"/>
+            </a:solidFill>
+            <a:prstDash val="solid"/>
+          </a:ln>
+        </p:spPr>
+      </p:sp>
+      <p:sp>
+        <p:nvSpPr>
+          <p:cNvPr id="7" name="Text 5"/>
+          <p:cNvSpPr/>
+          <p:nvPr/>
+        </p:nvSpPr>
+        <p:spPr>
+          <a:xfrm>
+            <a:off x="804672" y="1060704"/>
+            <a:ext cx="4928616" cy="237744"/>
+          </a:xfrm>
+          <a:prstGeom prst="rect">
+            <a:avLst/>
+          </a:prstGeom>
+          <a:noFill/>
+          <a:ln/>
+        </p:spPr>
+        <p:txBody>
+          <a:bodyPr wrap="square" lIns="0" tIns="0" rIns="0" bIns="0" rtlCol="0" anchor="ctr"/>
+          <a:lstStyle/>
+          <a:p>
+            <a:pPr indent="0" marL="0">
+              <a:buNone/>
+            </a:pPr>
+            <a:r>
+              <a:rPr lang="en-US" sz="1200" b="1" dirty="0">
+                <a:solidFill>
+                  <a:srgbClr val="1F5FBF"/>
+                </a:solidFill>
+              </a:rPr>
+              <a:t>보안/세션 보완</a:t>
+            </a:r>
+            <a:endParaRPr lang="en-US" sz="1200" dirty="0"/>
+          </a:p>
+        </p:txBody>
+      </p:sp>
+      <p:sp>
+        <p:nvSpPr>
+          <p:cNvPr id="8" name="Text 6"/>
+          <p:cNvSpPr/>
+          <p:nvPr/>
+        </p:nvSpPr>
+        <p:spPr>
+          <a:xfrm>
+            <a:off x="804672" y="1389888"/>
+            <a:ext cx="4928616" cy="502920"/>
+          </a:xfrm>
+          <a:prstGeom prst="rect">
+            <a:avLst/>
+          </a:prstGeom>
+          <a:noFill/>
+          <a:ln/>
+        </p:spPr>
+        <p:txBody>
+          <a:bodyPr wrap="square" lIns="381" tIns="381" rIns="381" bIns="381" rtlCol="0" anchor="ctr">
+            <a:normAutofit/>
+          </a:bodyPr>
+          <a:lstStyle/>
+          <a:p>
+            <a:pPr indent="0" marL="0">
+              <a:buNone/>
+            </a:pPr>
+            <a:r>
+              <a:rPr lang="en-US" sz="1070" dirty="0">
+                <a:solidFill>
+                  <a:srgbClr val="182230"/>
+                </a:solidFill>
+              </a:rPr>
+              <a:t>비밀번호는 Salt+SHA-256 해시로 저장하고, 로그인 상태는 HttpOnly 쿠키 세션으로 관리</a:t>
+            </a:r>
+            <a:endParaRPr lang="en-US" sz="1070" dirty="0"/>
+          </a:p>
+        </p:txBody>
+      </p:sp>
+      <p:sp>
+        <p:nvSpPr>
+          <p:cNvPr id="9" name="Shape 7"/>
+          <p:cNvSpPr/>
+          <p:nvPr/>
+        </p:nvSpPr>
+        <p:spPr>
+          <a:xfrm>
+            <a:off x="6263640" y="914400"/>
+            <a:ext cx="5257800" cy="1097280"/>
+          </a:xfrm>
+          <a:prstGeom prst="roundRect">
+            <a:avLst>
+              <a:gd name="adj" fmla="val 5000"/>
+            </a:avLst>
+          </a:prstGeom>
+          <a:solidFill>
+            <a:srgbClr val="FFFFFF"/>
+          </a:solidFill>
+          <a:ln w="12700">
+            <a:solidFill>
+              <a:srgbClr val="D7DEEA"/>
+            </a:solidFill>
+            <a:prstDash val="solid"/>
+          </a:ln>
+        </p:spPr>
+      </p:sp>
+      <p:sp>
+        <p:nvSpPr>
+          <p:cNvPr id="10" name="Text 8"/>
+          <p:cNvSpPr/>
+          <p:nvPr/>
+        </p:nvSpPr>
+        <p:spPr>
+          <a:xfrm>
+            <a:off x="6428232" y="1060704"/>
+            <a:ext cx="4928616" cy="237744"/>
+          </a:xfrm>
+          <a:prstGeom prst="rect">
+            <a:avLst/>
+          </a:prstGeom>
+          <a:noFill/>
+          <a:ln/>
+        </p:spPr>
+        <p:txBody>
+          <a:bodyPr wrap="square" lIns="0" tIns="0" rIns="0" bIns="0" rtlCol="0" anchor="ctr"/>
+          <a:lstStyle/>
+          <a:p>
+            <a:pPr indent="0" marL="0">
+              <a:buNone/>
+            </a:pPr>
+            <a:r>
+              <a:rPr lang="en-US" sz="1200" b="1" dirty="0">
+                <a:solidFill>
+                  <a:srgbClr val="1F5FBF"/>
+                </a:solidFill>
+              </a:rPr>
+              <a:t>WebSocket 보완</a:t>
+            </a:r>
+            <a:endParaRPr lang="en-US" sz="1200" dirty="0"/>
+          </a:p>
+        </p:txBody>
+      </p:sp>
+      <p:sp>
+        <p:nvSpPr>
+          <p:cNvPr id="11" name="Text 9"/>
+          <p:cNvSpPr/>
+          <p:nvPr/>
+        </p:nvSpPr>
+        <p:spPr>
+          <a:xfrm>
+            <a:off x="6428232" y="1389888"/>
+            <a:ext cx="4928616" cy="502920"/>
+          </a:xfrm>
+          <a:prstGeom prst="rect">
+            <a:avLst/>
+          </a:prstGeom>
+          <a:noFill/>
+          <a:ln/>
+        </p:spPr>
+        <p:txBody>
+          <a:bodyPr wrap="square" lIns="381" tIns="381" rIns="381" bIns="381" rtlCol="0" anchor="ctr">
+            <a:normAutofit/>
+          </a:bodyPr>
+          <a:lstStyle/>
+          <a:p>
+            <a:pPr indent="0" marL="0">
+              <a:buNone/>
+            </a:pPr>
+            <a:r>
+              <a:rPr lang="en-US" sz="1070" dirty="0">
+                <a:solidFill>
+                  <a:srgbClr val="182230"/>
+                </a:solidFill>
+              </a:rPr>
+              <a:t>KIS WebSocket 시작/오류 시 REST 폴링으로 자동 전환되도록 코드 보강</a:t>
+            </a:r>
+            <a:endParaRPr lang="en-US" sz="1070" dirty="0"/>
+          </a:p>
+        </p:txBody>
+      </p:sp>
+      <p:sp>
+        <p:nvSpPr>
+          <p:cNvPr id="12" name="Shape 10"/>
+          <p:cNvSpPr/>
+          <p:nvPr/>
+        </p:nvSpPr>
+        <p:spPr>
+          <a:xfrm>
+            <a:off x="640080" y="2514600"/>
+            <a:ext cx="5257800" cy="1097280"/>
+          </a:xfrm>
+          <a:prstGeom prst="roundRect">
+            <a:avLst>
+              <a:gd name="adj" fmla="val 5000"/>
+            </a:avLst>
+          </a:prstGeom>
+          <a:solidFill>
+            <a:srgbClr val="FFFFFF"/>
+          </a:solidFill>
+          <a:ln w="12700">
+            <a:solidFill>
+              <a:srgbClr val="D7DEEA"/>
+            </a:solidFill>
+            <a:prstDash val="solid"/>
+          </a:ln>
+        </p:spPr>
+      </p:sp>
+      <p:sp>
+        <p:nvSpPr>
+          <p:cNvPr id="13" name="Text 11"/>
+          <p:cNvSpPr/>
+          <p:nvPr/>
+        </p:nvSpPr>
+        <p:spPr>
+          <a:xfrm>
+            <a:off x="804672" y="2660904"/>
+            <a:ext cx="4928616" cy="237744"/>
+          </a:xfrm>
+          <a:prstGeom prst="rect">
+            <a:avLst/>
+          </a:prstGeom>
+          <a:noFill/>
+          <a:ln/>
+        </p:spPr>
+        <p:txBody>
+          <a:bodyPr wrap="square" lIns="0" tIns="0" rIns="0" bIns="0" rtlCol="0" anchor="ctr"/>
+          <a:lstStyle/>
+          <a:p>
+            <a:pPr indent="0" marL="0">
+              <a:buNone/>
+            </a:pPr>
+            <a:r>
+              <a:rPr lang="en-US" sz="1200" b="1" dirty="0">
+                <a:solidFill>
+                  <a:srgbClr val="1F5FBF"/>
+                </a:solidFill>
+              </a:rPr>
+              <a:t>남은 검증</a:t>
+            </a:r>
+            <a:endParaRPr lang="en-US" sz="1200" dirty="0"/>
+          </a:p>
+        </p:txBody>
+      </p:sp>
+      <p:sp>
+        <p:nvSpPr>
+          <p:cNvPr id="14" name="Text 12"/>
+          <p:cNvSpPr/>
+          <p:nvPr/>
+        </p:nvSpPr>
+        <p:spPr>
+          <a:xfrm>
+            <a:off x="804672" y="2990088"/>
+            <a:ext cx="4928616" cy="502920"/>
+          </a:xfrm>
+          <a:prstGeom prst="rect">
+            <a:avLst/>
+          </a:prstGeom>
+          <a:noFill/>
+          <a:ln/>
+        </p:spPr>
+        <p:txBody>
+          <a:bodyPr wrap="square" lIns="381" tIns="381" rIns="381" bIns="381" rtlCol="0" anchor="ctr">
+            <a:normAutofit/>
+          </a:bodyPr>
+          <a:lstStyle/>
+          <a:p>
+            <a:pPr indent="0" marL="0">
+              <a:buNone/>
+            </a:pPr>
+            <a:r>
+              <a:rPr lang="en-US" sz="1070" dirty="0">
+                <a:solidFill>
+                  <a:srgbClr val="182230"/>
+                </a:solidFill>
+              </a:rPr>
+              <a:t>실제 KIS 테스트베드에서 구독 성공 여부와 메시지 필드 순서 확인 필요</a:t>
+            </a:r>
+            <a:endParaRPr lang="en-US" sz="1070" dirty="0"/>
+          </a:p>
+        </p:txBody>
+      </p:sp>
+      <p:sp>
+        <p:nvSpPr>
+          <p:cNvPr id="15" name="Shape 13"/>
+          <p:cNvSpPr/>
+          <p:nvPr/>
+        </p:nvSpPr>
+        <p:spPr>
+          <a:xfrm>
+            <a:off x="6263640" y="2514600"/>
+            <a:ext cx="5257800" cy="1097280"/>
+          </a:xfrm>
+          <a:prstGeom prst="roundRect">
+            <a:avLst>
+              <a:gd name="adj" fmla="val 5000"/>
+            </a:avLst>
+          </a:prstGeom>
+          <a:solidFill>
+            <a:srgbClr val="FFFFFF"/>
+          </a:solidFill>
+          <a:ln w="12700">
+            <a:solidFill>
+              <a:srgbClr val="D7DEEA"/>
+            </a:solidFill>
+            <a:prstDash val="solid"/>
+          </a:ln>
+        </p:spPr>
+      </p:sp>
+      <p:sp>
+        <p:nvSpPr>
+          <p:cNvPr id="16" name="Text 14"/>
+          <p:cNvSpPr/>
+          <p:nvPr/>
+        </p:nvSpPr>
+        <p:spPr>
+          <a:xfrm>
+            <a:off x="6428232" y="2660904"/>
+            <a:ext cx="4928616" cy="237744"/>
+          </a:xfrm>
+          <a:prstGeom prst="rect">
+            <a:avLst/>
+          </a:prstGeom>
+          <a:noFill/>
+          <a:ln/>
+        </p:spPr>
+        <p:txBody>
+          <a:bodyPr wrap="square" lIns="0" tIns="0" rIns="0" bIns="0" rtlCol="0" anchor="ctr"/>
+          <a:lstStyle/>
+          <a:p>
+            <a:pPr indent="0" marL="0">
+              <a:buNone/>
+            </a:pPr>
+            <a:r>
+              <a:rPr lang="en-US" sz="1200" b="1" dirty="0">
+                <a:solidFill>
+                  <a:srgbClr val="1F5FBF"/>
+                </a:solidFill>
+              </a:rPr>
+              <a:t>구조 개선 계획</a:t>
+            </a:r>
+            <a:endParaRPr lang="en-US" sz="1200" dirty="0"/>
+          </a:p>
+        </p:txBody>
+      </p:sp>
+      <p:sp>
+        <p:nvSpPr>
+          <p:cNvPr id="17" name="Text 15"/>
+          <p:cNvSpPr/>
+          <p:nvPr/>
+        </p:nvSpPr>
+        <p:spPr>
+          <a:xfrm>
+            <a:off x="6428232" y="2990088"/>
+            <a:ext cx="4928616" cy="502920"/>
+          </a:xfrm>
+          <a:prstGeom prst="rect">
+            <a:avLst/>
+          </a:prstGeom>
+          <a:noFill/>
+          <a:ln/>
+        </p:spPr>
+        <p:txBody>
+          <a:bodyPr wrap="square" lIns="381" tIns="381" rIns="381" bIns="381" rtlCol="0" anchor="ctr">
+            <a:normAutofit/>
+          </a:bodyPr>
+          <a:lstStyle/>
+          <a:p>
+            <a:pPr indent="0" marL="0">
+              <a:buNone/>
+            </a:pPr>
+            <a:r>
+              <a:rPr lang="en-US" sz="1070" dirty="0">
+                <a:solidFill>
+                  <a:srgbClr val="182230"/>
+                </a:solidFill>
+              </a:rPr>
+              <a:t>현재는 루트 파일 중심, 이후 controller/service/repository/model 패키지 분리 예정</a:t>
+            </a:r>
+            <a:endParaRPr lang="en-US" sz="1070" dirty="0"/>
+          </a:p>
+        </p:txBody>
+      </p:sp>
+      <p:sp>
+        <p:nvSpPr>
+          <p:cNvPr id="18" name="Shape 16"/>
+          <p:cNvSpPr/>
+          <p:nvPr/>
+        </p:nvSpPr>
+        <p:spPr>
+          <a:xfrm>
+            <a:off x="640080" y="4114800"/>
+            <a:ext cx="5257800" cy="1097280"/>
+          </a:xfrm>
+          <a:prstGeom prst="roundRect">
+            <a:avLst>
+              <a:gd name="adj" fmla="val 5000"/>
+            </a:avLst>
+          </a:prstGeom>
+          <a:solidFill>
+            <a:srgbClr val="FFFFFF"/>
+          </a:solidFill>
+          <a:ln w="12700">
+            <a:solidFill>
+              <a:srgbClr val="D7DEEA"/>
+            </a:solidFill>
+            <a:prstDash val="solid"/>
+          </a:ln>
+        </p:spPr>
+      </p:sp>
+      <p:sp>
+        <p:nvSpPr>
+          <p:cNvPr id="19" name="Text 17"/>
+          <p:cNvSpPr/>
+          <p:nvPr/>
+        </p:nvSpPr>
+        <p:spPr>
+          <a:xfrm>
+            <a:off x="804672" y="4261104"/>
+            <a:ext cx="4928616" cy="237744"/>
+          </a:xfrm>
+          <a:prstGeom prst="rect">
+            <a:avLst/>
+          </a:prstGeom>
+          <a:noFill/>
+          <a:ln/>
+        </p:spPr>
+        <p:txBody>
+          <a:bodyPr wrap="square" lIns="0" tIns="0" rIns="0" bIns="0" rtlCol="0" anchor="ctr"/>
+          <a:lstStyle/>
+          <a:p>
+            <a:pPr indent="0" marL="0">
+              <a:buNone/>
+            </a:pPr>
+            <a:r>
+              <a:rPr lang="en-US" sz="1200" b="1" dirty="0">
+                <a:solidFill>
+                  <a:srgbClr val="1F5FBF"/>
+                </a:solidFill>
+              </a:rPr>
+              <a:t>추가 아이디어</a:t>
+            </a:r>
+            <a:endParaRPr lang="en-US" sz="1200" dirty="0"/>
+          </a:p>
+        </p:txBody>
+      </p:sp>
+      <p:sp>
+        <p:nvSpPr>
+          <p:cNvPr id="20" name="Text 18"/>
+          <p:cNvSpPr/>
+          <p:nvPr/>
+        </p:nvSpPr>
+        <p:spPr>
+          <a:xfrm>
+            <a:off x="804672" y="4590288"/>
+            <a:ext cx="4928616" cy="502920"/>
+          </a:xfrm>
+          <a:prstGeom prst="rect">
+            <a:avLst/>
+          </a:prstGeom>
+          <a:noFill/>
+          <a:ln/>
+        </p:spPr>
+        <p:txBody>
+          <a:bodyPr wrap="square" lIns="381" tIns="381" rIns="381" bIns="381" rtlCol="0" anchor="ctr">
+            <a:normAutofit/>
+          </a:bodyPr>
+          <a:lstStyle/>
+          <a:p>
+            <a:pPr indent="0" marL="0">
+              <a:buNone/>
+            </a:pPr>
+            <a:r>
+              <a:rPr lang="en-US" sz="1070" dirty="0">
+                <a:solidFill>
+                  <a:srgbClr val="182230"/>
+                </a:solidFill>
+              </a:rPr>
+              <a:t>업종별 위험 등급 표시, 개인화 관심종목 추천, 테스트 코드 보강</a:t>
+            </a:r>
+            <a:endParaRPr lang="en-US" sz="1070" dirty="0"/>
+          </a:p>
+        </p:txBody>
+      </p:sp>
+      <p:sp>
+        <p:nvSpPr>
+          <p:cNvPr id="21" name="Shape 19"/>
+          <p:cNvSpPr/>
+          <p:nvPr/>
+        </p:nvSpPr>
+        <p:spPr>
+          <a:xfrm>
+            <a:off x="6263640" y="4114800"/>
+            <a:ext cx="5257800" cy="1097280"/>
+          </a:xfrm>
+          <a:prstGeom prst="roundRect">
+            <a:avLst>
+              <a:gd name="adj" fmla="val 5000"/>
+            </a:avLst>
+          </a:prstGeom>
+          <a:solidFill>
+            <a:srgbClr val="EAF2FF"/>
+          </a:solidFill>
+          <a:ln w="12700">
+            <a:solidFill>
+              <a:srgbClr val="D7DEEA"/>
+            </a:solidFill>
+            <a:prstDash val="solid"/>
+          </a:ln>
+        </p:spPr>
+      </p:sp>
+      <p:sp>
+        <p:nvSpPr>
+          <p:cNvPr id="22" name="Text 20"/>
+          <p:cNvSpPr/>
+          <p:nvPr/>
+        </p:nvSpPr>
+        <p:spPr>
+          <a:xfrm>
+            <a:off x="6428232" y="4261104"/>
+            <a:ext cx="4928616" cy="237744"/>
+          </a:xfrm>
+          <a:prstGeom prst="rect">
+            <a:avLst/>
+          </a:prstGeom>
+          <a:noFill/>
+          <a:ln/>
+        </p:spPr>
+        <p:txBody>
+          <a:bodyPr wrap="square" lIns="0" tIns="0" rIns="0" bIns="0" rtlCol="0" anchor="ctr"/>
+          <a:lstStyle/>
+          <a:p>
+            <a:pPr indent="0" marL="0">
+              <a:buNone/>
+            </a:pPr>
+            <a:r>
+              <a:rPr lang="en-US" sz="1200" b="1" dirty="0">
+                <a:solidFill>
+                  <a:srgbClr val="1F5FBF"/>
+                </a:solidFill>
+              </a:rPr>
+              <a:t>배포 보완</a:t>
+            </a:r>
+            <a:endParaRPr lang="en-US" sz="1200" dirty="0"/>
+          </a:p>
+        </p:txBody>
+      </p:sp>
+      <p:sp>
+        <p:nvSpPr>
+          <p:cNvPr id="23" name="Text 21"/>
+          <p:cNvSpPr/>
+          <p:nvPr/>
+        </p:nvSpPr>
+        <p:spPr>
+          <a:xfrm>
+            <a:off x="6428232" y="4590288"/>
+            <a:ext cx="4928616" cy="502920"/>
+          </a:xfrm>
+          <a:prstGeom prst="rect">
+            <a:avLst/>
+          </a:prstGeom>
+          <a:noFill/>
+          <a:ln/>
+        </p:spPr>
+        <p:txBody>
+          <a:bodyPr wrap="square" lIns="381" tIns="381" rIns="381" bIns="381" rtlCol="0" anchor="ctr">
+            <a:normAutofit/>
+          </a:bodyPr>
+          <a:lstStyle/>
+          <a:p>
+            <a:pPr indent="0" marL="0">
+              <a:buNone/>
+            </a:pPr>
+            <a:r>
+              <a:rPr lang="en-US" sz="1070" dirty="0">
+                <a:solidFill>
+                  <a:srgbClr val="182230"/>
+                </a:solidFill>
+              </a:rPr>
+              <a:t>HTTPS, 세션 만료 시간, CSRF 방어는 실제 배포 단계에서 추가 필요</a:t>
+            </a:r>
+            <a:endParaRPr lang="en-US" sz="1070" dirty="0"/>
+          </a:p>
+        </p:txBody>
+      </p:sp>
+    </p:spTree>
+  </p:cSld>
+  <p:clrMapOvr>
+    <a:masterClrMapping/>
+  </p:clrMapOvr>
+</p:sld>
+</file>
+
+<file path=ppt/slides/slide16.xml><?xml version="1.0" encoding="utf-8"?>
+<p:sld xmlns:a="http://schemas.openxmlformats.org/drawingml/2006/main" xmlns:r="http://schemas.openxmlformats.org/officeDocument/2006/relationships" xmlns:p="http://schemas.openxmlformats.org/presentationml/2006/main">
+  <p:cSld name="Slide 16">
+    <p:spTree>
+      <p:nvGrpSpPr>
+        <p:cNvPr id="1" name=""/>
+        <p:cNvGrpSpPr/>
+        <p:nvPr/>
+      </p:nvGrpSpPr>
+      <p:grpSpPr>
+        <a:xfrm>
+          <a:off x="0" y="0"/>
+          <a:ext cx="0" cy="0"/>
+          <a:chOff x="0" y="0"/>
+          <a:chExt cx="0" cy="0"/>
+        </a:xfrm>
+      </p:grpSpPr>
+      <p:sp>
+        <p:nvSpPr>
+          <p:cNvPr id="2" name="Text 0"/>
+          <p:cNvSpPr/>
+          <p:nvPr/>
+        </p:nvSpPr>
+        <p:spPr>
+          <a:xfrm>
+            <a:off x="320040" y="182880"/>
+            <a:ext cx="411480" cy="228600"/>
+          </a:xfrm>
+          <a:prstGeom prst="rect">
+            <a:avLst/>
+          </a:prstGeom>
+          <a:noFill/>
+          <a:ln/>
+        </p:spPr>
+        <p:txBody>
+          <a:bodyPr wrap="square" lIns="0" tIns="0" rIns="0" bIns="0" rtlCol="0" anchor="ctr"/>
+          <a:lstStyle/>
+          <a:p>
+            <a:pPr indent="0" marL="0">
+              <a:buNone/>
+            </a:pPr>
+            <a:r>
+              <a:rPr lang="en-US" sz="800" b="1" dirty="0">
+                <a:solidFill>
+                  <a:srgbClr val="1F5FBF"/>
+                </a:solidFill>
+                <a:latin typeface="Malgun Gothic" pitchFamily="34" charset="0"/>
+                <a:ea typeface="Malgun Gothic" pitchFamily="34" charset="-122"/>
+                <a:cs typeface="Malgun Gothic" pitchFamily="34" charset="-120"/>
+              </a:rPr>
+              <a:t>16</a:t>
+            </a:r>
+            <a:endParaRPr lang="en-US" sz="800" dirty="0"/>
+          </a:p>
+        </p:txBody>
+      </p:sp>
+      <p:sp>
+        <p:nvSpPr>
+          <p:cNvPr id="3" name="Text 1"/>
+          <p:cNvSpPr/>
+          <p:nvPr/>
+        </p:nvSpPr>
+        <p:spPr>
+          <a:xfrm>
+            <a:off x="822960" y="137160"/>
+            <a:ext cx="8961120" cy="320040"/>
+          </a:xfrm>
+          <a:prstGeom prst="rect">
+            <a:avLst/>
+          </a:prstGeom>
+          <a:noFill/>
+          <a:ln/>
+        </p:spPr>
+        <p:txBody>
+          <a:bodyPr wrap="square" lIns="0" tIns="0" rIns="0" bIns="0" rtlCol="0" anchor="ctr"/>
+          <a:lstStyle/>
+          <a:p>
+            <a:pPr indent="0" marL="0">
+              <a:buNone/>
+            </a:pPr>
+            <a:r>
+              <a:rPr lang="en-US" sz="1600" b="1" dirty="0">
+                <a:solidFill>
+                  <a:srgbClr val="182230"/>
+                </a:solidFill>
+                <a:latin typeface="Malgun Gothic" pitchFamily="34" charset="0"/>
+                <a:ea typeface="Malgun Gothic" pitchFamily="34" charset="-122"/>
+                <a:cs typeface="Malgun Gothic" pitchFamily="34" charset="-120"/>
+              </a:rPr>
               <a:t>시연 영상 구성</a:t>
             </a:r>
             <a:endParaRPr lang="en-US" sz="1600" dirty="0"/>
@@ -11060,7 +11864,7 @@
         <p:spPr>
           <a:xfrm>
             <a:off x="640080" y="868680"/>
-            <a:ext cx="3730752" cy="640080"/>
+            <a:ext cx="3730752" cy="568960"/>
           </a:xfrm>
           <a:prstGeom prst="rect">
             <a:avLst/>
@@ -11085,7 +11889,7 @@
         <p:spPr>
           <a:xfrm>
             <a:off x="713232" y="941832"/>
-            <a:ext cx="3584448" cy="512064"/>
+            <a:ext cx="3584448" cy="440944"/>
           </a:xfrm>
           <a:prstGeom prst="rect">
             <a:avLst/>
@@ -11123,7 +11927,7 @@
         <p:spPr>
           <a:xfrm>
             <a:off x="4370832" y="868680"/>
-            <a:ext cx="7242048" cy="640080"/>
+            <a:ext cx="7242048" cy="568960"/>
           </a:xfrm>
           <a:prstGeom prst="rect">
             <a:avLst/>
@@ -11148,7 +11952,7 @@
         <p:spPr>
           <a:xfrm>
             <a:off x="4443984" y="941832"/>
-            <a:ext cx="7095744" cy="512064"/>
+            <a:ext cx="7095744" cy="440944"/>
           </a:xfrm>
           <a:prstGeom prst="rect">
             <a:avLst/>
@@ -11185,8 +11989,8 @@
         </p:nvSpPr>
         <p:spPr>
           <a:xfrm>
-            <a:off x="640080" y="1508760"/>
-            <a:ext cx="3730752" cy="640080"/>
+            <a:off x="640080" y="1437640"/>
+            <a:ext cx="3730752" cy="568960"/>
           </a:xfrm>
           <a:prstGeom prst="rect">
             <a:avLst/>
@@ -11210,8 +12014,8 @@
         </p:nvSpPr>
         <p:spPr>
           <a:xfrm>
-            <a:off x="713232" y="1581912"/>
-            <a:ext cx="3584448" cy="512064"/>
+            <a:off x="713232" y="1510792"/>
+            <a:ext cx="3584448" cy="440944"/>
           </a:xfrm>
           <a:prstGeom prst="rect">
             <a:avLst/>
@@ -11248,8 +12052,8 @@
         </p:nvSpPr>
         <p:spPr>
           <a:xfrm>
-            <a:off x="4370832" y="1508760"/>
-            <a:ext cx="7242048" cy="640080"/>
+            <a:off x="4370832" y="1437640"/>
+            <a:ext cx="7242048" cy="568960"/>
           </a:xfrm>
           <a:prstGeom prst="rect">
             <a:avLst/>
@@ -11273,8 +12077,8 @@
         </p:nvSpPr>
         <p:spPr>
           <a:xfrm>
-            <a:off x="4443984" y="1581912"/>
-            <a:ext cx="7095744" cy="512064"/>
+            <a:off x="4443984" y="1510792"/>
+            <a:ext cx="7095744" cy="440944"/>
           </a:xfrm>
           <a:prstGeom prst="rect">
             <a:avLst/>
@@ -11311,8 +12115,8 @@
         </p:nvSpPr>
         <p:spPr>
           <a:xfrm>
-            <a:off x="640080" y="2148840"/>
-            <a:ext cx="3730752" cy="640080"/>
+            <a:off x="640080" y="2006600"/>
+            <a:ext cx="3730752" cy="568960"/>
           </a:xfrm>
           <a:prstGeom prst="rect">
             <a:avLst/>
@@ -11336,8 +12140,8 @@
         </p:nvSpPr>
         <p:spPr>
           <a:xfrm>
-            <a:off x="713232" y="2221992"/>
-            <a:ext cx="3584448" cy="512064"/>
+            <a:off x="713232" y="2079752"/>
+            <a:ext cx="3584448" cy="440944"/>
           </a:xfrm>
           <a:prstGeom prst="rect">
             <a:avLst/>
@@ -11374,8 +12178,8 @@
         </p:nvSpPr>
         <p:spPr>
           <a:xfrm>
-            <a:off x="4370832" y="2148840"/>
-            <a:ext cx="7242048" cy="640080"/>
+            <a:off x="4370832" y="2006600"/>
+            <a:ext cx="7242048" cy="568960"/>
           </a:xfrm>
           <a:prstGeom prst="rect">
             <a:avLst/>
@@ -11399,8 +12203,8 @@
         </p:nvSpPr>
         <p:spPr>
           <a:xfrm>
-            <a:off x="4443984" y="2221992"/>
-            <a:ext cx="7095744" cy="512064"/>
+            <a:off x="4443984" y="2079752"/>
+            <a:ext cx="7095744" cy="440944"/>
           </a:xfrm>
           <a:prstGeom prst="rect">
             <a:avLst/>
@@ -11437,8 +12241,8 @@
         </p:nvSpPr>
         <p:spPr>
           <a:xfrm>
-            <a:off x="640080" y="2788920"/>
-            <a:ext cx="3730752" cy="640080"/>
+            <a:off x="640080" y="2575560"/>
+            <a:ext cx="3730752" cy="568960"/>
           </a:xfrm>
           <a:prstGeom prst="rect">
             <a:avLst/>
@@ -11462,8 +12266,8 @@
         </p:nvSpPr>
         <p:spPr>
           <a:xfrm>
-            <a:off x="713232" y="2862072"/>
-            <a:ext cx="3584448" cy="512064"/>
+            <a:off x="713232" y="2648712"/>
+            <a:ext cx="3584448" cy="440944"/>
           </a:xfrm>
           <a:prstGeom prst="rect">
             <a:avLst/>
@@ -11500,8 +12304,8 @@
         </p:nvSpPr>
         <p:spPr>
           <a:xfrm>
-            <a:off x="4370832" y="2788920"/>
-            <a:ext cx="7242048" cy="640080"/>
+            <a:off x="4370832" y="2575560"/>
+            <a:ext cx="7242048" cy="568960"/>
           </a:xfrm>
           <a:prstGeom prst="rect">
             <a:avLst/>
@@ -11525,8 +12329,8 @@
         </p:nvSpPr>
         <p:spPr>
           <a:xfrm>
-            <a:off x="4443984" y="2862072"/>
-            <a:ext cx="7095744" cy="512064"/>
+            <a:off x="4443984" y="2648712"/>
+            <a:ext cx="7095744" cy="440944"/>
           </a:xfrm>
           <a:prstGeom prst="rect">
             <a:avLst/>
@@ -11563,8 +12367,8 @@
         </p:nvSpPr>
         <p:spPr>
           <a:xfrm>
-            <a:off x="640080" y="3429000"/>
-            <a:ext cx="3730752" cy="640080"/>
+            <a:off x="640080" y="3144520"/>
+            <a:ext cx="3730752" cy="568960"/>
           </a:xfrm>
           <a:prstGeom prst="rect">
             <a:avLst/>
@@ -11588,8 +12392,8 @@
         </p:nvSpPr>
         <p:spPr>
           <a:xfrm>
-            <a:off x="713232" y="3502152"/>
-            <a:ext cx="3584448" cy="512064"/>
+            <a:off x="713232" y="3217672"/>
+            <a:ext cx="3584448" cy="440944"/>
           </a:xfrm>
           <a:prstGeom prst="rect">
             <a:avLst/>
@@ -11626,8 +12430,8 @@
         </p:nvSpPr>
         <p:spPr>
           <a:xfrm>
-            <a:off x="4370832" y="3429000"/>
-            <a:ext cx="7242048" cy="640080"/>
+            <a:off x="4370832" y="3144520"/>
+            <a:ext cx="7242048" cy="568960"/>
           </a:xfrm>
           <a:prstGeom prst="rect">
             <a:avLst/>
@@ -11651,8 +12455,8 @@
         </p:nvSpPr>
         <p:spPr>
           <a:xfrm>
-            <a:off x="4443984" y="3502152"/>
-            <a:ext cx="7095744" cy="512064"/>
+            <a:off x="4443984" y="3217672"/>
+            <a:ext cx="7095744" cy="440944"/>
           </a:xfrm>
           <a:prstGeom prst="rect">
             <a:avLst/>
@@ -11689,8 +12493,8 @@
         </p:nvSpPr>
         <p:spPr>
           <a:xfrm>
-            <a:off x="640080" y="4069080"/>
-            <a:ext cx="3730752" cy="640080"/>
+            <a:off x="640080" y="3713480"/>
+            <a:ext cx="3730752" cy="568960"/>
           </a:xfrm>
           <a:prstGeom prst="rect">
             <a:avLst/>
@@ -11714,8 +12518,8 @@
         </p:nvSpPr>
         <p:spPr>
           <a:xfrm>
-            <a:off x="713232" y="4142232"/>
-            <a:ext cx="3584448" cy="512064"/>
+            <a:off x="713232" y="3786632"/>
+            <a:ext cx="3584448" cy="440944"/>
           </a:xfrm>
           <a:prstGeom prst="rect">
             <a:avLst/>
@@ -11752,8 +12556,8 @@
         </p:nvSpPr>
         <p:spPr>
           <a:xfrm>
-            <a:off x="4370832" y="4069080"/>
-            <a:ext cx="7242048" cy="640080"/>
+            <a:off x="4370832" y="3713480"/>
+            <a:ext cx="7242048" cy="568960"/>
           </a:xfrm>
           <a:prstGeom prst="rect">
             <a:avLst/>
@@ -11777,8 +12581,8 @@
         </p:nvSpPr>
         <p:spPr>
           <a:xfrm>
-            <a:off x="4443984" y="4142232"/>
-            <a:ext cx="7095744" cy="512064"/>
+            <a:off x="4443984" y="3786632"/>
+            <a:ext cx="7095744" cy="440944"/>
           </a:xfrm>
           <a:prstGeom prst="rect">
             <a:avLst/>
@@ -11815,8 +12619,8 @@
         </p:nvSpPr>
         <p:spPr>
           <a:xfrm>
-            <a:off x="640080" y="4709160"/>
-            <a:ext cx="3730752" cy="640080"/>
+            <a:off x="640080" y="4282440"/>
+            <a:ext cx="3730752" cy="568960"/>
           </a:xfrm>
           <a:prstGeom prst="rect">
             <a:avLst/>
@@ -11840,8 +12644,8 @@
         </p:nvSpPr>
         <p:spPr>
           <a:xfrm>
-            <a:off x="713232" y="4782312"/>
-            <a:ext cx="3584448" cy="512064"/>
+            <a:off x="713232" y="4355592"/>
+            <a:ext cx="3584448" cy="440944"/>
           </a:xfrm>
           <a:prstGeom prst="rect">
             <a:avLst/>
@@ -11864,7 +12668,7 @@
                   <a:srgbClr val="182230"/>
                 </a:solidFill>
               </a:rPr>
-              <a:t>StockCategoryProfiles.java</a:t>
+              <a:t>PasswordHasher.java</a:t>
             </a:r>
             <a:endParaRPr lang="en-US" sz="920" dirty="0"/>
           </a:p>
@@ -11878,8 +12682,8 @@
         </p:nvSpPr>
         <p:spPr>
           <a:xfrm>
-            <a:off x="4370832" y="4709160"/>
-            <a:ext cx="7242048" cy="640080"/>
+            <a:off x="4370832" y="4282440"/>
+            <a:ext cx="7242048" cy="568960"/>
           </a:xfrm>
           <a:prstGeom prst="rect">
             <a:avLst/>
@@ -11903,8 +12707,8 @@
         </p:nvSpPr>
         <p:spPr>
           <a:xfrm>
-            <a:off x="4443984" y="4782312"/>
-            <a:ext cx="7095744" cy="512064"/>
+            <a:off x="4443984" y="4355592"/>
+            <a:ext cx="7095744" cy="440944"/>
           </a:xfrm>
           <a:prstGeom prst="rect">
             <a:avLst/>
@@ -11927,7 +12731,7 @@
                   <a:srgbClr val="182230"/>
                 </a:solidFill>
               </a:rPr>
-              <a:t>업종·테마별 종목 분류 타입</a:t>
+              <a:t>Salt 기반 SHA-256 비밀번호 해시와 검증</a:t>
             </a:r>
             <a:endParaRPr lang="en-US" sz="920" dirty="0"/>
           </a:p>
@@ -11941,8 +12745,8 @@
         </p:nvSpPr>
         <p:spPr>
           <a:xfrm>
-            <a:off x="640080" y="5349240"/>
-            <a:ext cx="3730752" cy="640080"/>
+            <a:off x="640080" y="4851400"/>
+            <a:ext cx="3730752" cy="568960"/>
           </a:xfrm>
           <a:prstGeom prst="rect">
             <a:avLst/>
@@ -11966,8 +12770,8 @@
         </p:nvSpPr>
         <p:spPr>
           <a:xfrm>
-            <a:off x="713232" y="5422392"/>
-            <a:ext cx="3584448" cy="512064"/>
+            <a:off x="713232" y="4924552"/>
+            <a:ext cx="3584448" cy="440944"/>
           </a:xfrm>
           <a:prstGeom prst="rect">
             <a:avLst/>
@@ -11990,6 +12794,132 @@
                   <a:srgbClr val="182230"/>
                 </a:solidFill>
               </a:rPr>
+              <a:t>StockCategoryProfiles.java</a:t>
+            </a:r>
+            <a:endParaRPr lang="en-US" sz="920" dirty="0"/>
+          </a:p>
+        </p:txBody>
+      </p:sp>
+      <p:sp>
+        <p:nvSpPr>
+          <p:cNvPr id="36" name="Shape 34"/>
+          <p:cNvSpPr/>
+          <p:nvPr/>
+        </p:nvSpPr>
+        <p:spPr>
+          <a:xfrm>
+            <a:off x="4370832" y="4851400"/>
+            <a:ext cx="7242048" cy="568960"/>
+          </a:xfrm>
+          <a:prstGeom prst="rect">
+            <a:avLst/>
+          </a:prstGeom>
+          <a:solidFill>
+            <a:srgbClr val="FFFFFF"/>
+          </a:solidFill>
+          <a:ln w="7620">
+            <a:solidFill>
+              <a:srgbClr val="D7DEEA"/>
+            </a:solidFill>
+            <a:prstDash val="solid"/>
+          </a:ln>
+        </p:spPr>
+      </p:sp>
+      <p:sp>
+        <p:nvSpPr>
+          <p:cNvPr id="37" name="Text 35"/>
+          <p:cNvSpPr/>
+          <p:nvPr/>
+        </p:nvSpPr>
+        <p:spPr>
+          <a:xfrm>
+            <a:off x="4443984" y="4924552"/>
+            <a:ext cx="7095744" cy="440944"/>
+          </a:xfrm>
+          <a:prstGeom prst="rect">
+            <a:avLst/>
+          </a:prstGeom>
+          <a:noFill/>
+          <a:ln/>
+        </p:spPr>
+        <p:txBody>
+          <a:bodyPr wrap="square" lIns="0" tIns="0" rIns="0" bIns="0" rtlCol="0" anchor="ctr">
+            <a:normAutofit/>
+          </a:bodyPr>
+          <a:lstStyle/>
+          <a:p>
+            <a:pPr indent="0" marL="0">
+              <a:buNone/>
+            </a:pPr>
+            <a:r>
+              <a:rPr lang="en-US" sz="920" dirty="0">
+                <a:solidFill>
+                  <a:srgbClr val="182230"/>
+                </a:solidFill>
+              </a:rPr>
+              <a:t>업종·테마별 종목 분류 타입</a:t>
+            </a:r>
+            <a:endParaRPr lang="en-US" sz="920" dirty="0"/>
+          </a:p>
+        </p:txBody>
+      </p:sp>
+      <p:sp>
+        <p:nvSpPr>
+          <p:cNvPr id="38" name="Shape 36"/>
+          <p:cNvSpPr/>
+          <p:nvPr/>
+        </p:nvSpPr>
+        <p:spPr>
+          <a:xfrm>
+            <a:off x="640080" y="5420360"/>
+            <a:ext cx="3730752" cy="568960"/>
+          </a:xfrm>
+          <a:prstGeom prst="rect">
+            <a:avLst/>
+          </a:prstGeom>
+          <a:solidFill>
+            <a:srgbClr val="F6F9FD"/>
+          </a:solidFill>
+          <a:ln w="7620">
+            <a:solidFill>
+              <a:srgbClr val="D7DEEA"/>
+            </a:solidFill>
+            <a:prstDash val="solid"/>
+          </a:ln>
+        </p:spPr>
+      </p:sp>
+      <p:sp>
+        <p:nvSpPr>
+          <p:cNvPr id="39" name="Text 37"/>
+          <p:cNvSpPr/>
+          <p:nvPr/>
+        </p:nvSpPr>
+        <p:spPr>
+          <a:xfrm>
+            <a:off x="713232" y="5493512"/>
+            <a:ext cx="3584448" cy="440944"/>
+          </a:xfrm>
+          <a:prstGeom prst="rect">
+            <a:avLst/>
+          </a:prstGeom>
+          <a:noFill/>
+          <a:ln/>
+        </p:spPr>
+        <p:txBody>
+          <a:bodyPr wrap="square" lIns="0" tIns="0" rIns="0" bIns="0" rtlCol="0" anchor="ctr">
+            <a:normAutofit/>
+          </a:bodyPr>
+          <a:lstStyle/>
+          <a:p>
+            <a:pPr indent="0" marL="0">
+              <a:buNone/>
+            </a:pPr>
+            <a:r>
+              <a:rPr lang="en-US" sz="920" dirty="0">
+                <a:solidFill>
+                  <a:srgbClr val="182230"/>
+                </a:solidFill>
+              </a:rPr>
               <a:t>WebPages.java</a:t>
             </a:r>
             <a:endParaRPr lang="en-US" sz="920" dirty="0"/>
@@ -11998,20 +12928,20 @@
       </p:sp>
       <p:sp>
         <p:nvSpPr>
-          <p:cNvPr id="36" name="Shape 34"/>
-          <p:cNvSpPr/>
-          <p:nvPr/>
-        </p:nvSpPr>
-        <p:spPr>
-          <a:xfrm>
-            <a:off x="4370832" y="5349240"/>
-            <a:ext cx="7242048" cy="640080"/>
-          </a:xfrm>
-          <a:prstGeom prst="rect">
-            <a:avLst/>
-          </a:prstGeom>
-          <a:solidFill>
-            <a:srgbClr val="FFFFFF"/>
+          <p:cNvPr id="40" name="Shape 38"/>
+          <p:cNvSpPr/>
+          <p:nvPr/>
+        </p:nvSpPr>
+        <p:spPr>
+          <a:xfrm>
+            <a:off x="4370832" y="5420360"/>
+            <a:ext cx="7242048" cy="568960"/>
+          </a:xfrm>
+          <a:prstGeom prst="rect">
+            <a:avLst/>
+          </a:prstGeom>
+          <a:solidFill>
+            <a:srgbClr val="F6F9FD"/>
           </a:solidFill>
           <a:ln w="7620">
             <a:solidFill>
@@ -12023,14 +12953,14 @@
       </p:sp>
       <p:sp>
         <p:nvSpPr>
-          <p:cNvPr id="37" name="Text 35"/>
-          <p:cNvSpPr/>
-          <p:nvPr/>
-        </p:nvSpPr>
-        <p:spPr>
-          <a:xfrm>
-            <a:off x="4443984" y="5422392"/>
-            <a:ext cx="7095744" cy="512064"/>
+          <p:cNvPr id="41" name="Text 39"/>
+          <p:cNvSpPr/>
+          <p:nvPr/>
+        </p:nvSpPr>
+        <p:spPr>
+          <a:xfrm>
+            <a:off x="4443984" y="5493512"/>
+            <a:ext cx="7095744" cy="440944"/>
           </a:xfrm>
           <a:prstGeom prst="rect">
             <a:avLst/>

</xml_diff>